<commit_message>
vault backup: 2026-09-15 16:23:25
</commit_message>
<xml_diff>
--- a/概率论与数理统计/原始材料/MIT18.600/中文版/Lecture38_复习练习_中文.pptx
+++ b/概率论与数理统计/原始材料/MIT18.600/中文版/Lecture38_复习练习_中文.pptx
@@ -3177,8 +3177,8 @@
         </p:nvSpPr>
         <p:spPr>
           <a:xfrm>
-            <a:off x="502920" y="1508760"/>
-            <a:ext cx="11155680" cy="4846320"/>
+            <a:off x="502920" y="1554480"/>
+            <a:ext cx="11155680" cy="4937760"/>
           </a:xfrm>
           <a:prstGeom prst="rect">
             <a:avLst/>
@@ -3191,15 +3191,15 @@
           </a:bodyPr>
           <a:lstStyle/>
           <a:p>
-            <a:pPr lvl="1">
+            <a:pPr>
               <a:spcAft>
                 <a:spcPts val="1000"/>
               </a:spcAft>
             </a:pPr>
             <a:r>
-              <a:rPr sz="1700">
-                <a:solidFill>
-                  <a:srgbClr val="404040"/>
+              <a:rPr sz="1900">
+                <a:solidFill>
+                  <a:srgbClr val="202020"/>
                 </a:solidFill>
                 <a:latin typeface="Microsoft YaHei"/>
               </a:rPr>
@@ -3302,8 +3302,8 @@
         </p:nvSpPr>
         <p:spPr>
           <a:xfrm>
-            <a:off x="502920" y="1005840"/>
-            <a:ext cx="11155680" cy="4846320"/>
+            <a:off x="502920" y="1051560"/>
+            <a:ext cx="11155680" cy="4937760"/>
           </a:xfrm>
           <a:prstGeom prst="rect">
             <a:avLst/>
@@ -3328,7 +3328,149 @@
                 </a:solidFill>
                 <a:latin typeface="Microsoft YaHei"/>
               </a:rPr>
-              <a:t>▶ 设 X、Y 为独立随机变量，各以概率 1/3 取值 1，以概率 2/3 取值 2。</a:t>
+              <a:t>▶ 设 </a:t>
+            </a:r>
+            <mc:AlternateContent xmlns:mc="http://schemas.openxmlformats.org/markup-compatibility/2006" xmlns:a14="http://schemas.microsoft.com/office/drawing/2010/main" mc:Ignorable="a14">
+              <mc:Choice Requires="a14">
+                <a14:m>
+                  <m:oMath xmlns:m="http://schemas.openxmlformats.org/officeDocument/2006/math">
+                    <m:r>
+                      <m:rPr>
+                        <m:sz m:val="38"/>
+                      </m:rPr>
+                      <m:t>X</m:t>
+                    </m:r>
+                  </m:oMath>
+                </a14:m>
+              </mc:Choice>
+              <mc:Fallback>
+                <a:r>
+                  <a:t>X</a:t>
+                </a:r>
+              </mc:Fallback>
+            </mc:AlternateContent>
+            <a:r>
+              <a:rPr sz="1900">
+                <a:solidFill>
+                  <a:srgbClr val="202020"/>
+                </a:solidFill>
+                <a:latin typeface="Microsoft YaHei"/>
+              </a:rPr>
+              <a:t>、</a:t>
+            </a:r>
+            <mc:AlternateContent xmlns:mc="http://schemas.openxmlformats.org/markup-compatibility/2006" xmlns:a14="http://schemas.microsoft.com/office/drawing/2010/main" mc:Ignorable="a14">
+              <mc:Choice Requires="a14">
+                <a14:m>
+                  <m:oMath xmlns:m="http://schemas.openxmlformats.org/officeDocument/2006/math">
+                    <m:r>
+                      <m:rPr>
+                        <m:sz m:val="38"/>
+                      </m:rPr>
+                      <m:t>Y</m:t>
+                    </m:r>
+                  </m:oMath>
+                </a14:m>
+              </mc:Choice>
+              <mc:Fallback>
+                <a:r>
+                  <a:t>Y</a:t>
+                </a:r>
+              </mc:Fallback>
+            </mc:AlternateContent>
+            <a:r>
+              <a:rPr sz="1900">
+                <a:solidFill>
+                  <a:srgbClr val="202020"/>
+                </a:solidFill>
+                <a:latin typeface="Microsoft YaHei"/>
+              </a:rPr>
+              <a:t> 为独立随机变量，各以概率 </a:t>
+            </a:r>
+            <mc:AlternateContent xmlns:mc="http://schemas.openxmlformats.org/markup-compatibility/2006" xmlns:a14="http://schemas.microsoft.com/office/drawing/2010/main" mc:Ignorable="a14">
+              <mc:Choice Requires="a14">
+                <a14:m>
+                  <m:oMath xmlns:m="http://schemas.openxmlformats.org/officeDocument/2006/math">
+                    <m:f>
+                      <m:fPr>
+                        <m:type m:val="lin"/>
+                      </m:fPr>
+                      <m:num>
+                        <m:r>
+                          <m:rPr>
+                            <m:sz m:val="38"/>
+                          </m:rPr>
+                          <m:t>1</m:t>
+                        </m:r>
+                      </m:num>
+                      <m:den>
+                        <m:r>
+                          <m:rPr>
+                            <m:sz m:val="38"/>
+                          </m:rPr>
+                          <m:t>3</m:t>
+                        </m:r>
+                      </m:den>
+                    </m:f>
+                  </m:oMath>
+                </a14:m>
+              </mc:Choice>
+              <mc:Fallback>
+                <a:r>
+                  <a:t>1/3</a:t>
+                </a:r>
+              </mc:Fallback>
+            </mc:AlternateContent>
+            <a:r>
+              <a:rPr sz="1900">
+                <a:solidFill>
+                  <a:srgbClr val="202020"/>
+                </a:solidFill>
+                <a:latin typeface="Microsoft YaHei"/>
+              </a:rPr>
+              <a:t> 取值 1，以概率 </a:t>
+            </a:r>
+            <mc:AlternateContent xmlns:mc="http://schemas.openxmlformats.org/markup-compatibility/2006" xmlns:a14="http://schemas.microsoft.com/office/drawing/2010/main" mc:Ignorable="a14">
+              <mc:Choice Requires="a14">
+                <a14:m>
+                  <m:oMath xmlns:m="http://schemas.openxmlformats.org/officeDocument/2006/math">
+                    <m:f>
+                      <m:fPr>
+                        <m:type m:val="lin"/>
+                      </m:fPr>
+                      <m:num>
+                        <m:r>
+                          <m:rPr>
+                            <m:sz m:val="38"/>
+                          </m:rPr>
+                          <m:t>2</m:t>
+                        </m:r>
+                      </m:num>
+                      <m:den>
+                        <m:r>
+                          <m:rPr>
+                            <m:sz m:val="38"/>
+                          </m:rPr>
+                          <m:t>3</m:t>
+                        </m:r>
+                      </m:den>
+                    </m:f>
+                  </m:oMath>
+                </a14:m>
+              </mc:Choice>
+              <mc:Fallback>
+                <a:r>
+                  <a:t>2/3</a:t>
+                </a:r>
+              </mc:Fallback>
+            </mc:AlternateContent>
+            <a:r>
+              <a:rPr sz="1900">
+                <a:solidFill>
+                  <a:srgbClr val="202020"/>
+                </a:solidFill>
+                <a:latin typeface="Microsoft YaHei"/>
+              </a:rPr>
+              <a:t> 取值 2。</a:t>
             </a:r>
           </a:p>
           <a:p>
@@ -3344,8 +3486,27 @@
                 </a:solidFill>
                 <a:latin typeface="Microsoft YaHei"/>
               </a:rPr>
-              <a:t>▶ 计算熵 H(X)。</a:t>
-            </a:r>
+              <a:t>▶ 计算熵 </a:t>
+            </a:r>
+            <mc:AlternateContent xmlns:mc="http://schemas.openxmlformats.org/markup-compatibility/2006" xmlns:a14="http://schemas.microsoft.com/office/drawing/2010/main" mc:Ignorable="a14">
+              <mc:Choice Requires="a14">
+                <a14:m>
+                  <m:oMath xmlns:m="http://schemas.openxmlformats.org/officeDocument/2006/math">
+                    <m:r>
+                      <m:rPr>
+                        <m:sz m:val="38"/>
+                      </m:rPr>
+                      <m:t>H(X)</m:t>
+                    </m:r>
+                  </m:oMath>
+                </a14:m>
+              </mc:Choice>
+              <mc:Fallback>
+                <a:r>
+                  <a:t>H(X)</a:t>
+                </a:r>
+              </mc:Fallback>
+            </mc:AlternateContent>
           </a:p>
           <a:p>
             <a:pPr>
@@ -3360,8 +3521,27 @@
                 </a:solidFill>
                 <a:latin typeface="Microsoft YaHei"/>
               </a:rPr>
-              <a:t>▶ 计算 H(X + Y)。</a:t>
-            </a:r>
+              <a:t>▶ 计算 </a:t>
+            </a:r>
+            <mc:AlternateContent xmlns:mc="http://schemas.openxmlformats.org/markup-compatibility/2006" xmlns:a14="http://schemas.microsoft.com/office/drawing/2010/main" mc:Ignorable="a14">
+              <mc:Choice Requires="a14">
+                <a14:m>
+                  <m:oMath xmlns:m="http://schemas.openxmlformats.org/officeDocument/2006/math">
+                    <m:r>
+                      <m:rPr>
+                        <m:sz m:val="38"/>
+                      </m:rPr>
+                      <m:t>H(X+Y)</m:t>
+                    </m:r>
+                  </m:oMath>
+                </a14:m>
+              </mc:Choice>
+              <mc:Fallback>
+                <a:r>
+                  <a:t>H(X+Y)</a:t>
+                </a:r>
+              </mc:Fallback>
+            </mc:AlternateContent>
           </a:p>
         </p:txBody>
       </p:sp>
@@ -3459,8 +3639,8 @@
         </p:nvSpPr>
         <p:spPr>
           <a:xfrm>
-            <a:off x="502920" y="1005840"/>
-            <a:ext cx="11155680" cy="4846320"/>
+            <a:off x="502920" y="1051560"/>
+            <a:ext cx="11155680" cy="4937760"/>
           </a:xfrm>
           <a:prstGeom prst="rect">
             <a:avLst/>
@@ -3485,7 +3665,149 @@
                 </a:solidFill>
                 <a:latin typeface="Microsoft YaHei"/>
               </a:rPr>
-              <a:t>▶ 设 X、Y 为独立随机变量，各以概率 1/3 取值 1，以概率 2/3 取值 2。</a:t>
+              <a:t>▶ 设 </a:t>
+            </a:r>
+            <mc:AlternateContent xmlns:mc="http://schemas.openxmlformats.org/markup-compatibility/2006" xmlns:a14="http://schemas.microsoft.com/office/drawing/2010/main" mc:Ignorable="a14">
+              <mc:Choice Requires="a14">
+                <a14:m>
+                  <m:oMath xmlns:m="http://schemas.openxmlformats.org/officeDocument/2006/math">
+                    <m:r>
+                      <m:rPr>
+                        <m:sz m:val="38"/>
+                      </m:rPr>
+                      <m:t>X</m:t>
+                    </m:r>
+                  </m:oMath>
+                </a14:m>
+              </mc:Choice>
+              <mc:Fallback>
+                <a:r>
+                  <a:t>X</a:t>
+                </a:r>
+              </mc:Fallback>
+            </mc:AlternateContent>
+            <a:r>
+              <a:rPr sz="1900">
+                <a:solidFill>
+                  <a:srgbClr val="202020"/>
+                </a:solidFill>
+                <a:latin typeface="Microsoft YaHei"/>
+              </a:rPr>
+              <a:t>、</a:t>
+            </a:r>
+            <mc:AlternateContent xmlns:mc="http://schemas.openxmlformats.org/markup-compatibility/2006" xmlns:a14="http://schemas.microsoft.com/office/drawing/2010/main" mc:Ignorable="a14">
+              <mc:Choice Requires="a14">
+                <a14:m>
+                  <m:oMath xmlns:m="http://schemas.openxmlformats.org/officeDocument/2006/math">
+                    <m:r>
+                      <m:rPr>
+                        <m:sz m:val="38"/>
+                      </m:rPr>
+                      <m:t>Y</m:t>
+                    </m:r>
+                  </m:oMath>
+                </a14:m>
+              </mc:Choice>
+              <mc:Fallback>
+                <a:r>
+                  <a:t>Y</a:t>
+                </a:r>
+              </mc:Fallback>
+            </mc:AlternateContent>
+            <a:r>
+              <a:rPr sz="1900">
+                <a:solidFill>
+                  <a:srgbClr val="202020"/>
+                </a:solidFill>
+                <a:latin typeface="Microsoft YaHei"/>
+              </a:rPr>
+              <a:t> 为独立随机变量，各以概率 </a:t>
+            </a:r>
+            <mc:AlternateContent xmlns:mc="http://schemas.openxmlformats.org/markup-compatibility/2006" xmlns:a14="http://schemas.microsoft.com/office/drawing/2010/main" mc:Ignorable="a14">
+              <mc:Choice Requires="a14">
+                <a14:m>
+                  <m:oMath xmlns:m="http://schemas.openxmlformats.org/officeDocument/2006/math">
+                    <m:f>
+                      <m:fPr>
+                        <m:type m:val="lin"/>
+                      </m:fPr>
+                      <m:num>
+                        <m:r>
+                          <m:rPr>
+                            <m:sz m:val="38"/>
+                          </m:rPr>
+                          <m:t>1</m:t>
+                        </m:r>
+                      </m:num>
+                      <m:den>
+                        <m:r>
+                          <m:rPr>
+                            <m:sz m:val="38"/>
+                          </m:rPr>
+                          <m:t>3</m:t>
+                        </m:r>
+                      </m:den>
+                    </m:f>
+                  </m:oMath>
+                </a14:m>
+              </mc:Choice>
+              <mc:Fallback>
+                <a:r>
+                  <a:t>1/3</a:t>
+                </a:r>
+              </mc:Fallback>
+            </mc:AlternateContent>
+            <a:r>
+              <a:rPr sz="1900">
+                <a:solidFill>
+                  <a:srgbClr val="202020"/>
+                </a:solidFill>
+                <a:latin typeface="Microsoft YaHei"/>
+              </a:rPr>
+              <a:t> 取值 1，以概率 </a:t>
+            </a:r>
+            <mc:AlternateContent xmlns:mc="http://schemas.openxmlformats.org/markup-compatibility/2006" xmlns:a14="http://schemas.microsoft.com/office/drawing/2010/main" mc:Ignorable="a14">
+              <mc:Choice Requires="a14">
+                <a14:m>
+                  <m:oMath xmlns:m="http://schemas.openxmlformats.org/officeDocument/2006/math">
+                    <m:f>
+                      <m:fPr>
+                        <m:type m:val="lin"/>
+                      </m:fPr>
+                      <m:num>
+                        <m:r>
+                          <m:rPr>
+                            <m:sz m:val="38"/>
+                          </m:rPr>
+                          <m:t>2</m:t>
+                        </m:r>
+                      </m:num>
+                      <m:den>
+                        <m:r>
+                          <m:rPr>
+                            <m:sz m:val="38"/>
+                          </m:rPr>
+                          <m:t>3</m:t>
+                        </m:r>
+                      </m:den>
+                    </m:f>
+                  </m:oMath>
+                </a14:m>
+              </mc:Choice>
+              <mc:Fallback>
+                <a:r>
+                  <a:t>2/3</a:t>
+                </a:r>
+              </mc:Fallback>
+            </mc:AlternateContent>
+            <a:r>
+              <a:rPr sz="1900">
+                <a:solidFill>
+                  <a:srgbClr val="202020"/>
+                </a:solidFill>
+                <a:latin typeface="Microsoft YaHei"/>
+              </a:rPr>
+              <a:t> 取值 2。</a:t>
             </a:r>
           </a:p>
           <a:p>
@@ -3501,8 +3823,27 @@
                 </a:solidFill>
                 <a:latin typeface="Microsoft YaHei"/>
               </a:rPr>
-              <a:t>▶ 计算熵 H(X)。</a:t>
-            </a:r>
+              <a:t>▶ 计算熵 </a:t>
+            </a:r>
+            <mc:AlternateContent xmlns:mc="http://schemas.openxmlformats.org/markup-compatibility/2006" xmlns:a14="http://schemas.microsoft.com/office/drawing/2010/main" mc:Ignorable="a14">
+              <mc:Choice Requires="a14">
+                <a14:m>
+                  <m:oMath xmlns:m="http://schemas.openxmlformats.org/officeDocument/2006/math">
+                    <m:r>
+                      <m:rPr>
+                        <m:sz m:val="38"/>
+                      </m:rPr>
+                      <m:t>H(X)</m:t>
+                    </m:r>
+                  </m:oMath>
+                </a14:m>
+              </mc:Choice>
+              <mc:Fallback>
+                <a:r>
+                  <a:t>H(X)</a:t>
+                </a:r>
+              </mc:Fallback>
+            </mc:AlternateContent>
           </a:p>
           <a:p>
             <a:pPr>
@@ -3517,8 +3858,27 @@
                 </a:solidFill>
                 <a:latin typeface="Microsoft YaHei"/>
               </a:rPr>
-              <a:t>▶ 计算 H(X + Y)。</a:t>
-            </a:r>
+              <a:t>▶ 计算 </a:t>
+            </a:r>
+            <mc:AlternateContent xmlns:mc="http://schemas.openxmlformats.org/markup-compatibility/2006" xmlns:a14="http://schemas.microsoft.com/office/drawing/2010/main" mc:Ignorable="a14">
+              <mc:Choice Requires="a14">
+                <a14:m>
+                  <m:oMath xmlns:m="http://schemas.openxmlformats.org/officeDocument/2006/math">
+                    <m:r>
+                      <m:rPr>
+                        <m:sz m:val="38"/>
+                      </m:rPr>
+                      <m:t>H(X+Y)</m:t>
+                    </m:r>
+                  </m:oMath>
+                </a14:m>
+              </mc:Choice>
+              <mc:Fallback>
+                <a:r>
+                  <a:t>H(X+Y)</a:t>
+                </a:r>
+              </mc:Fallback>
+            </mc:AlternateContent>
           </a:p>
           <a:p>
             <a:pPr>
@@ -3533,7 +3893,119 @@
                 </a:solidFill>
                 <a:latin typeface="Microsoft YaHei"/>
               </a:rPr>
-              <a:t>▶ H(X + Y) 与 H(X, Y) 哪个更大？对任意离散随机变量 X、Y，结论是否依然成立？请解释。</a:t>
+              <a:t>▶ </a:t>
+            </a:r>
+            <mc:AlternateContent xmlns:mc="http://schemas.openxmlformats.org/markup-compatibility/2006" xmlns:a14="http://schemas.microsoft.com/office/drawing/2010/main" mc:Ignorable="a14">
+              <mc:Choice Requires="a14">
+                <a14:m>
+                  <m:oMath xmlns:m="http://schemas.openxmlformats.org/officeDocument/2006/math">
+                    <m:r>
+                      <m:rPr>
+                        <m:sz m:val="38"/>
+                      </m:rPr>
+                      <m:t>H(X+Y)</m:t>
+                    </m:r>
+                  </m:oMath>
+                </a14:m>
+              </mc:Choice>
+              <mc:Fallback>
+                <a:r>
+                  <a:t>H(X+Y)</a:t>
+                </a:r>
+              </mc:Fallback>
+            </mc:AlternateContent>
+            <a:r>
+              <a:rPr sz="1900">
+                <a:solidFill>
+                  <a:srgbClr val="202020"/>
+                </a:solidFill>
+                <a:latin typeface="Microsoft YaHei"/>
+              </a:rPr>
+              <a:t> 与 </a:t>
+            </a:r>
+            <mc:AlternateContent xmlns:mc="http://schemas.openxmlformats.org/markup-compatibility/2006" xmlns:a14="http://schemas.microsoft.com/office/drawing/2010/main" mc:Ignorable="a14">
+              <mc:Choice Requires="a14">
+                <a14:m>
+                  <m:oMath xmlns:m="http://schemas.openxmlformats.org/officeDocument/2006/math">
+                    <m:r>
+                      <m:rPr>
+                        <m:sz m:val="38"/>
+                      </m:rPr>
+                      <m:t>H(X,Y)</m:t>
+                    </m:r>
+                  </m:oMath>
+                </a14:m>
+              </mc:Choice>
+              <mc:Fallback>
+                <a:r>
+                  <a:t>H(X,Y)</a:t>
+                </a:r>
+              </mc:Fallback>
+            </mc:AlternateContent>
+            <a:r>
+              <a:rPr sz="1900">
+                <a:solidFill>
+                  <a:srgbClr val="202020"/>
+                </a:solidFill>
+                <a:latin typeface="Microsoft YaHei"/>
+              </a:rPr>
+              <a:t> 哪个更大？对任意离散随机变量 </a:t>
+            </a:r>
+            <mc:AlternateContent xmlns:mc="http://schemas.openxmlformats.org/markup-compatibility/2006" xmlns:a14="http://schemas.microsoft.com/office/drawing/2010/main" mc:Ignorable="a14">
+              <mc:Choice Requires="a14">
+                <a14:m>
+                  <m:oMath xmlns:m="http://schemas.openxmlformats.org/officeDocument/2006/math">
+                    <m:r>
+                      <m:rPr>
+                        <m:sz m:val="38"/>
+                      </m:rPr>
+                      <m:t>X</m:t>
+                    </m:r>
+                  </m:oMath>
+                </a14:m>
+              </mc:Choice>
+              <mc:Fallback>
+                <a:r>
+                  <a:t>X</a:t>
+                </a:r>
+              </mc:Fallback>
+            </mc:AlternateContent>
+            <a:r>
+              <a:rPr sz="1900">
+                <a:solidFill>
+                  <a:srgbClr val="202020"/>
+                </a:solidFill>
+                <a:latin typeface="Microsoft YaHei"/>
+              </a:rPr>
+              <a:t>、</a:t>
+            </a:r>
+            <mc:AlternateContent xmlns:mc="http://schemas.openxmlformats.org/markup-compatibility/2006" xmlns:a14="http://schemas.microsoft.com/office/drawing/2010/main" mc:Ignorable="a14">
+              <mc:Choice Requires="a14">
+                <a14:m>
+                  <m:oMath xmlns:m="http://schemas.openxmlformats.org/officeDocument/2006/math">
+                    <m:r>
+                      <m:rPr>
+                        <m:sz m:val="38"/>
+                      </m:rPr>
+                      <m:t>Y</m:t>
+                    </m:r>
+                  </m:oMath>
+                </a14:m>
+              </mc:Choice>
+              <mc:Fallback>
+                <a:r>
+                  <a:t>Y</a:t>
+                </a:r>
+              </mc:Fallback>
+            </mc:AlternateContent>
+            <a:r>
+              <a:rPr sz="1900">
+                <a:solidFill>
+                  <a:srgbClr val="202020"/>
+                </a:solidFill>
+                <a:latin typeface="Microsoft YaHei"/>
+              </a:rPr>
+              <a:t>，结论是否依然成立？请解释。</a:t>
             </a:r>
           </a:p>
         </p:txBody>
@@ -3632,8 +4104,8 @@
         </p:nvSpPr>
         <p:spPr>
           <a:xfrm>
-            <a:off x="502920" y="1005840"/>
-            <a:ext cx="11155680" cy="4846320"/>
+            <a:off x="502920" y="1051560"/>
+            <a:ext cx="11155680" cy="4937760"/>
           </a:xfrm>
           <a:prstGeom prst="rect">
             <a:avLst/>
@@ -3658,8 +4130,147 @@
                 </a:solidFill>
                 <a:latin typeface="Microsoft YaHei"/>
               </a:rPr>
-              <a:t>▶ H(X) = ⅓(−log ⅓) + ⅔(−log ⅔)</a:t>
-            </a:r>
+              <a:t>▶ </a:t>
+            </a:r>
+            <mc:AlternateContent xmlns:mc="http://schemas.openxmlformats.org/markup-compatibility/2006" xmlns:a14="http://schemas.microsoft.com/office/drawing/2010/main" mc:Ignorable="a14">
+              <mc:Choice Requires="a14">
+                <a14:m>
+                  <m:oMath xmlns:m="http://schemas.openxmlformats.org/officeDocument/2006/math">
+                    <m:r>
+                      <m:rPr>
+                        <m:sz m:val="38"/>
+                      </m:rPr>
+                      <m:t>H(X)=</m:t>
+                    </m:r>
+                    <m:f>
+                      <m:fPr>
+                        <m:type m:val="bar"/>
+                      </m:fPr>
+                      <m:num>
+                        <m:r>
+                          <m:rPr>
+                            <m:sz m:val="38"/>
+                          </m:rPr>
+                          <m:t>1</m:t>
+                        </m:r>
+                      </m:num>
+                      <m:den>
+                        <m:r>
+                          <m:rPr>
+                            <m:sz m:val="38"/>
+                          </m:rPr>
+                          <m:t>3</m:t>
+                        </m:r>
+                      </m:den>
+                    </m:f>
+                    <m:d>
+                      <m:dPr>
+                        <m:sepChr m:val="−"/>
+                      </m:dPr>
+                      <m:e/>
+                      <m:e>
+                        <m:r>
+                          <m:rPr>
+                            <m:sty m:val="p"/>
+                            <m:sz m:val="38"/>
+                          </m:rPr>
+                          <m:t>log</m:t>
+                        </m:r>
+                        <m:f>
+                          <m:fPr>
+                            <m:type m:val="bar"/>
+                          </m:fPr>
+                          <m:num>
+                            <m:r>
+                              <m:rPr>
+                                <m:sz m:val="38"/>
+                              </m:rPr>
+                              <m:t>1</m:t>
+                            </m:r>
+                          </m:num>
+                          <m:den>
+                            <m:r>
+                              <m:rPr>
+                                <m:sz m:val="38"/>
+                              </m:rPr>
+                              <m:t>3</m:t>
+                            </m:r>
+                          </m:den>
+                        </m:f>
+                      </m:e>
+                    </m:d>
+                    <m:r>
+                      <m:rPr>
+                        <m:sz m:val="38"/>
+                      </m:rPr>
+                      <m:t>+</m:t>
+                    </m:r>
+                    <m:f>
+                      <m:fPr>
+                        <m:type m:val="bar"/>
+                      </m:fPr>
+                      <m:num>
+                        <m:r>
+                          <m:rPr>
+                            <m:sz m:val="38"/>
+                          </m:rPr>
+                          <m:t>2</m:t>
+                        </m:r>
+                      </m:num>
+                      <m:den>
+                        <m:r>
+                          <m:rPr>
+                            <m:sz m:val="38"/>
+                          </m:rPr>
+                          <m:t>3</m:t>
+                        </m:r>
+                      </m:den>
+                    </m:f>
+                    <m:d>
+                      <m:dPr>
+                        <m:sepChr m:val="−"/>
+                      </m:dPr>
+                      <m:e/>
+                      <m:e>
+                        <m:r>
+                          <m:rPr>
+                            <m:sty m:val="p"/>
+                            <m:sz m:val="38"/>
+                          </m:rPr>
+                          <m:t>log</m:t>
+                        </m:r>
+                        <m:f>
+                          <m:fPr>
+                            <m:type m:val="bar"/>
+                          </m:fPr>
+                          <m:num>
+                            <m:r>
+                              <m:rPr>
+                                <m:sz m:val="38"/>
+                              </m:rPr>
+                              <m:t>2</m:t>
+                            </m:r>
+                          </m:num>
+                          <m:den>
+                            <m:r>
+                              <m:rPr>
+                                <m:sz m:val="38"/>
+                              </m:rPr>
+                              <m:t>3</m:t>
+                            </m:r>
+                          </m:den>
+                        </m:f>
+                      </m:e>
+                    </m:d>
+                  </m:oMath>
+                </a14:m>
+              </mc:Choice>
+              <mc:Fallback>
+                <a:r>
+                  <a:t>H(X)=13(−log13)+23(−log23)</a:t>
+                </a:r>
+              </mc:Fallback>
+            </mc:AlternateContent>
           </a:p>
         </p:txBody>
       </p:sp>
@@ -3757,8 +4368,8 @@
         </p:nvSpPr>
         <p:spPr>
           <a:xfrm>
-            <a:off x="502920" y="1005840"/>
-            <a:ext cx="11155680" cy="4846320"/>
+            <a:off x="502920" y="1051560"/>
+            <a:ext cx="11155680" cy="4937760"/>
           </a:xfrm>
           <a:prstGeom prst="rect">
             <a:avLst/>
@@ -3783,8 +4394,147 @@
                 </a:solidFill>
                 <a:latin typeface="Microsoft YaHei"/>
               </a:rPr>
-              <a:t>▶ H(X) = ⅓(−log ⅓) + ⅔(−log ⅔)</a:t>
-            </a:r>
+              <a:t>▶ </a:t>
+            </a:r>
+            <mc:AlternateContent xmlns:mc="http://schemas.openxmlformats.org/markup-compatibility/2006" xmlns:a14="http://schemas.microsoft.com/office/drawing/2010/main" mc:Ignorable="a14">
+              <mc:Choice Requires="a14">
+                <a14:m>
+                  <m:oMath xmlns:m="http://schemas.openxmlformats.org/officeDocument/2006/math">
+                    <m:r>
+                      <m:rPr>
+                        <m:sz m:val="38"/>
+                      </m:rPr>
+                      <m:t>H(X)=</m:t>
+                    </m:r>
+                    <m:f>
+                      <m:fPr>
+                        <m:type m:val="bar"/>
+                      </m:fPr>
+                      <m:num>
+                        <m:r>
+                          <m:rPr>
+                            <m:sz m:val="38"/>
+                          </m:rPr>
+                          <m:t>1</m:t>
+                        </m:r>
+                      </m:num>
+                      <m:den>
+                        <m:r>
+                          <m:rPr>
+                            <m:sz m:val="38"/>
+                          </m:rPr>
+                          <m:t>3</m:t>
+                        </m:r>
+                      </m:den>
+                    </m:f>
+                    <m:d>
+                      <m:dPr>
+                        <m:sepChr m:val="−"/>
+                      </m:dPr>
+                      <m:e/>
+                      <m:e>
+                        <m:r>
+                          <m:rPr>
+                            <m:sty m:val="p"/>
+                            <m:sz m:val="38"/>
+                          </m:rPr>
+                          <m:t>log</m:t>
+                        </m:r>
+                        <m:f>
+                          <m:fPr>
+                            <m:type m:val="bar"/>
+                          </m:fPr>
+                          <m:num>
+                            <m:r>
+                              <m:rPr>
+                                <m:sz m:val="38"/>
+                              </m:rPr>
+                              <m:t>1</m:t>
+                            </m:r>
+                          </m:num>
+                          <m:den>
+                            <m:r>
+                              <m:rPr>
+                                <m:sz m:val="38"/>
+                              </m:rPr>
+                              <m:t>3</m:t>
+                            </m:r>
+                          </m:den>
+                        </m:f>
+                      </m:e>
+                    </m:d>
+                    <m:r>
+                      <m:rPr>
+                        <m:sz m:val="38"/>
+                      </m:rPr>
+                      <m:t>+</m:t>
+                    </m:r>
+                    <m:f>
+                      <m:fPr>
+                        <m:type m:val="bar"/>
+                      </m:fPr>
+                      <m:num>
+                        <m:r>
+                          <m:rPr>
+                            <m:sz m:val="38"/>
+                          </m:rPr>
+                          <m:t>2</m:t>
+                        </m:r>
+                      </m:num>
+                      <m:den>
+                        <m:r>
+                          <m:rPr>
+                            <m:sz m:val="38"/>
+                          </m:rPr>
+                          <m:t>3</m:t>
+                        </m:r>
+                      </m:den>
+                    </m:f>
+                    <m:d>
+                      <m:dPr>
+                        <m:sepChr m:val="−"/>
+                      </m:dPr>
+                      <m:e/>
+                      <m:e>
+                        <m:r>
+                          <m:rPr>
+                            <m:sty m:val="p"/>
+                            <m:sz m:val="38"/>
+                          </m:rPr>
+                          <m:t>log</m:t>
+                        </m:r>
+                        <m:f>
+                          <m:fPr>
+                            <m:type m:val="bar"/>
+                          </m:fPr>
+                          <m:num>
+                            <m:r>
+                              <m:rPr>
+                                <m:sz m:val="38"/>
+                              </m:rPr>
+                              <m:t>2</m:t>
+                            </m:r>
+                          </m:num>
+                          <m:den>
+                            <m:r>
+                              <m:rPr>
+                                <m:sz m:val="38"/>
+                              </m:rPr>
+                              <m:t>3</m:t>
+                            </m:r>
+                          </m:den>
+                        </m:f>
+                      </m:e>
+                    </m:d>
+                  </m:oMath>
+                </a14:m>
+              </mc:Choice>
+              <mc:Fallback>
+                <a:r>
+                  <a:t>H(X)=13(−log13)+23(−log23)</a:t>
+                </a:r>
+              </mc:Fallback>
+            </mc:AlternateContent>
           </a:p>
           <a:p>
             <a:pPr>
@@ -3799,8 +4549,210 @@
                 </a:solidFill>
                 <a:latin typeface="Microsoft YaHei"/>
               </a:rPr>
-              <a:t>▶ H(X + Y) = 1/9(−log 1/9) + 4/9(−log 4/9) + 4/9(−log 4/9)</a:t>
-            </a:r>
+              <a:t>▶ </a:t>
+            </a:r>
+            <mc:AlternateContent xmlns:mc="http://schemas.openxmlformats.org/markup-compatibility/2006" xmlns:a14="http://schemas.microsoft.com/office/drawing/2010/main" mc:Ignorable="a14">
+              <mc:Choice Requires="a14">
+                <a14:m>
+                  <m:oMath xmlns:m="http://schemas.openxmlformats.org/officeDocument/2006/math">
+                    <m:r>
+                      <m:rPr>
+                        <m:sz m:val="38"/>
+                      </m:rPr>
+                      <m:t>H(X+Y)=</m:t>
+                    </m:r>
+                    <m:f>
+                      <m:fPr>
+                        <m:type m:val="bar"/>
+                      </m:fPr>
+                      <m:num>
+                        <m:r>
+                          <m:rPr>
+                            <m:sz m:val="38"/>
+                          </m:rPr>
+                          <m:t>1</m:t>
+                        </m:r>
+                      </m:num>
+                      <m:den>
+                        <m:r>
+                          <m:rPr>
+                            <m:sz m:val="38"/>
+                          </m:rPr>
+                          <m:t>9</m:t>
+                        </m:r>
+                      </m:den>
+                    </m:f>
+                    <m:d>
+                      <m:dPr>
+                        <m:sepChr m:val="−"/>
+                      </m:dPr>
+                      <m:e/>
+                      <m:e>
+                        <m:r>
+                          <m:rPr>
+                            <m:sty m:val="p"/>
+                            <m:sz m:val="38"/>
+                          </m:rPr>
+                          <m:t>log</m:t>
+                        </m:r>
+                        <m:f>
+                          <m:fPr>
+                            <m:type m:val="bar"/>
+                          </m:fPr>
+                          <m:num>
+                            <m:r>
+                              <m:rPr>
+                                <m:sz m:val="38"/>
+                              </m:rPr>
+                              <m:t>1</m:t>
+                            </m:r>
+                          </m:num>
+                          <m:den>
+                            <m:r>
+                              <m:rPr>
+                                <m:sz m:val="38"/>
+                              </m:rPr>
+                              <m:t>9</m:t>
+                            </m:r>
+                          </m:den>
+                        </m:f>
+                      </m:e>
+                    </m:d>
+                    <m:r>
+                      <m:rPr>
+                        <m:sz m:val="38"/>
+                      </m:rPr>
+                      <m:t>+</m:t>
+                    </m:r>
+                    <m:f>
+                      <m:fPr>
+                        <m:type m:val="bar"/>
+                      </m:fPr>
+                      <m:num>
+                        <m:r>
+                          <m:rPr>
+                            <m:sz m:val="38"/>
+                          </m:rPr>
+                          <m:t>4</m:t>
+                        </m:r>
+                      </m:num>
+                      <m:den>
+                        <m:r>
+                          <m:rPr>
+                            <m:sz m:val="38"/>
+                          </m:rPr>
+                          <m:t>9</m:t>
+                        </m:r>
+                      </m:den>
+                    </m:f>
+                    <m:d>
+                      <m:dPr>
+                        <m:sepChr m:val="−"/>
+                      </m:dPr>
+                      <m:e/>
+                      <m:e>
+                        <m:r>
+                          <m:rPr>
+                            <m:sty m:val="p"/>
+                            <m:sz m:val="38"/>
+                          </m:rPr>
+                          <m:t>log</m:t>
+                        </m:r>
+                        <m:f>
+                          <m:fPr>
+                            <m:type m:val="bar"/>
+                          </m:fPr>
+                          <m:num>
+                            <m:r>
+                              <m:rPr>
+                                <m:sz m:val="38"/>
+                              </m:rPr>
+                              <m:t>4</m:t>
+                            </m:r>
+                          </m:num>
+                          <m:den>
+                            <m:r>
+                              <m:rPr>
+                                <m:sz m:val="38"/>
+                              </m:rPr>
+                              <m:t>9</m:t>
+                            </m:r>
+                          </m:den>
+                        </m:f>
+                      </m:e>
+                    </m:d>
+                    <m:r>
+                      <m:rPr>
+                        <m:sz m:val="38"/>
+                      </m:rPr>
+                      <m:t>+</m:t>
+                    </m:r>
+                    <m:f>
+                      <m:fPr>
+                        <m:type m:val="bar"/>
+                      </m:fPr>
+                      <m:num>
+                        <m:r>
+                          <m:rPr>
+                            <m:sz m:val="38"/>
+                          </m:rPr>
+                          <m:t>4</m:t>
+                        </m:r>
+                      </m:num>
+                      <m:den>
+                        <m:r>
+                          <m:rPr>
+                            <m:sz m:val="38"/>
+                          </m:rPr>
+                          <m:t>9</m:t>
+                        </m:r>
+                      </m:den>
+                    </m:f>
+                    <m:d>
+                      <m:dPr>
+                        <m:sepChr m:val="−"/>
+                      </m:dPr>
+                      <m:e/>
+                      <m:e>
+                        <m:r>
+                          <m:rPr>
+                            <m:sty m:val="p"/>
+                            <m:sz m:val="38"/>
+                          </m:rPr>
+                          <m:t>log</m:t>
+                        </m:r>
+                        <m:f>
+                          <m:fPr>
+                            <m:type m:val="bar"/>
+                          </m:fPr>
+                          <m:num>
+                            <m:r>
+                              <m:rPr>
+                                <m:sz m:val="38"/>
+                              </m:rPr>
+                              <m:t>4</m:t>
+                            </m:r>
+                          </m:num>
+                          <m:den>
+                            <m:r>
+                              <m:rPr>
+                                <m:sz m:val="38"/>
+                              </m:rPr>
+                              <m:t>9</m:t>
+                            </m:r>
+                          </m:den>
+                        </m:f>
+                      </m:e>
+                    </m:d>
+                  </m:oMath>
+                </a14:m>
+              </mc:Choice>
+              <mc:Fallback>
+                <a:r>
+                  <a:t>H(X+Y)=19(−log19)+49(−log49)+49(−log49)</a:t>
+                </a:r>
+              </mc:Fallback>
+            </mc:AlternateContent>
           </a:p>
         </p:txBody>
       </p:sp>
@@ -3898,8 +4850,8 @@
         </p:nvSpPr>
         <p:spPr>
           <a:xfrm>
-            <a:off x="502920" y="1005840"/>
-            <a:ext cx="11155680" cy="4846320"/>
+            <a:off x="502920" y="1051560"/>
+            <a:ext cx="11155680" cy="4937760"/>
           </a:xfrm>
           <a:prstGeom prst="rect">
             <a:avLst/>
@@ -3924,8 +4876,147 @@
                 </a:solidFill>
                 <a:latin typeface="Microsoft YaHei"/>
               </a:rPr>
-              <a:t>▶ H(X) = ⅓(−log ⅓) + ⅔(−log ⅔)</a:t>
-            </a:r>
+              <a:t>▶ </a:t>
+            </a:r>
+            <mc:AlternateContent xmlns:mc="http://schemas.openxmlformats.org/markup-compatibility/2006" xmlns:a14="http://schemas.microsoft.com/office/drawing/2010/main" mc:Ignorable="a14">
+              <mc:Choice Requires="a14">
+                <a14:m>
+                  <m:oMath xmlns:m="http://schemas.openxmlformats.org/officeDocument/2006/math">
+                    <m:r>
+                      <m:rPr>
+                        <m:sz m:val="38"/>
+                      </m:rPr>
+                      <m:t>H(X)=</m:t>
+                    </m:r>
+                    <m:f>
+                      <m:fPr>
+                        <m:type m:val="bar"/>
+                      </m:fPr>
+                      <m:num>
+                        <m:r>
+                          <m:rPr>
+                            <m:sz m:val="38"/>
+                          </m:rPr>
+                          <m:t>1</m:t>
+                        </m:r>
+                      </m:num>
+                      <m:den>
+                        <m:r>
+                          <m:rPr>
+                            <m:sz m:val="38"/>
+                          </m:rPr>
+                          <m:t>3</m:t>
+                        </m:r>
+                      </m:den>
+                    </m:f>
+                    <m:d>
+                      <m:dPr>
+                        <m:sepChr m:val="−"/>
+                      </m:dPr>
+                      <m:e/>
+                      <m:e>
+                        <m:r>
+                          <m:rPr>
+                            <m:sty m:val="p"/>
+                            <m:sz m:val="38"/>
+                          </m:rPr>
+                          <m:t>log</m:t>
+                        </m:r>
+                        <m:f>
+                          <m:fPr>
+                            <m:type m:val="bar"/>
+                          </m:fPr>
+                          <m:num>
+                            <m:r>
+                              <m:rPr>
+                                <m:sz m:val="38"/>
+                              </m:rPr>
+                              <m:t>1</m:t>
+                            </m:r>
+                          </m:num>
+                          <m:den>
+                            <m:r>
+                              <m:rPr>
+                                <m:sz m:val="38"/>
+                              </m:rPr>
+                              <m:t>3</m:t>
+                            </m:r>
+                          </m:den>
+                        </m:f>
+                      </m:e>
+                    </m:d>
+                    <m:r>
+                      <m:rPr>
+                        <m:sz m:val="38"/>
+                      </m:rPr>
+                      <m:t>+</m:t>
+                    </m:r>
+                    <m:f>
+                      <m:fPr>
+                        <m:type m:val="bar"/>
+                      </m:fPr>
+                      <m:num>
+                        <m:r>
+                          <m:rPr>
+                            <m:sz m:val="38"/>
+                          </m:rPr>
+                          <m:t>2</m:t>
+                        </m:r>
+                      </m:num>
+                      <m:den>
+                        <m:r>
+                          <m:rPr>
+                            <m:sz m:val="38"/>
+                          </m:rPr>
+                          <m:t>3</m:t>
+                        </m:r>
+                      </m:den>
+                    </m:f>
+                    <m:d>
+                      <m:dPr>
+                        <m:sepChr m:val="−"/>
+                      </m:dPr>
+                      <m:e/>
+                      <m:e>
+                        <m:r>
+                          <m:rPr>
+                            <m:sty m:val="p"/>
+                            <m:sz m:val="38"/>
+                          </m:rPr>
+                          <m:t>log</m:t>
+                        </m:r>
+                        <m:f>
+                          <m:fPr>
+                            <m:type m:val="bar"/>
+                          </m:fPr>
+                          <m:num>
+                            <m:r>
+                              <m:rPr>
+                                <m:sz m:val="38"/>
+                              </m:rPr>
+                              <m:t>2</m:t>
+                            </m:r>
+                          </m:num>
+                          <m:den>
+                            <m:r>
+                              <m:rPr>
+                                <m:sz m:val="38"/>
+                              </m:rPr>
+                              <m:t>3</m:t>
+                            </m:r>
+                          </m:den>
+                        </m:f>
+                      </m:e>
+                    </m:d>
+                  </m:oMath>
+                </a14:m>
+              </mc:Choice>
+              <mc:Fallback>
+                <a:r>
+                  <a:t>H(X)=13(−log13)+23(−log23)</a:t>
+                </a:r>
+              </mc:Fallback>
+            </mc:AlternateContent>
           </a:p>
           <a:p>
             <a:pPr>
@@ -3940,8 +5031,210 @@
                 </a:solidFill>
                 <a:latin typeface="Microsoft YaHei"/>
               </a:rPr>
-              <a:t>▶ H(X + Y) = 1/9(−log 1/9) + 4/9(−log 4/9) + 4/9(−log 4/9)</a:t>
-            </a:r>
+              <a:t>▶ </a:t>
+            </a:r>
+            <mc:AlternateContent xmlns:mc="http://schemas.openxmlformats.org/markup-compatibility/2006" xmlns:a14="http://schemas.microsoft.com/office/drawing/2010/main" mc:Ignorable="a14">
+              <mc:Choice Requires="a14">
+                <a14:m>
+                  <m:oMath xmlns:m="http://schemas.openxmlformats.org/officeDocument/2006/math">
+                    <m:r>
+                      <m:rPr>
+                        <m:sz m:val="38"/>
+                      </m:rPr>
+                      <m:t>H(X+Y)=</m:t>
+                    </m:r>
+                    <m:f>
+                      <m:fPr>
+                        <m:type m:val="bar"/>
+                      </m:fPr>
+                      <m:num>
+                        <m:r>
+                          <m:rPr>
+                            <m:sz m:val="38"/>
+                          </m:rPr>
+                          <m:t>1</m:t>
+                        </m:r>
+                      </m:num>
+                      <m:den>
+                        <m:r>
+                          <m:rPr>
+                            <m:sz m:val="38"/>
+                          </m:rPr>
+                          <m:t>9</m:t>
+                        </m:r>
+                      </m:den>
+                    </m:f>
+                    <m:d>
+                      <m:dPr>
+                        <m:sepChr m:val="−"/>
+                      </m:dPr>
+                      <m:e/>
+                      <m:e>
+                        <m:r>
+                          <m:rPr>
+                            <m:sty m:val="p"/>
+                            <m:sz m:val="38"/>
+                          </m:rPr>
+                          <m:t>log</m:t>
+                        </m:r>
+                        <m:f>
+                          <m:fPr>
+                            <m:type m:val="bar"/>
+                          </m:fPr>
+                          <m:num>
+                            <m:r>
+                              <m:rPr>
+                                <m:sz m:val="38"/>
+                              </m:rPr>
+                              <m:t>1</m:t>
+                            </m:r>
+                          </m:num>
+                          <m:den>
+                            <m:r>
+                              <m:rPr>
+                                <m:sz m:val="38"/>
+                              </m:rPr>
+                              <m:t>9</m:t>
+                            </m:r>
+                          </m:den>
+                        </m:f>
+                      </m:e>
+                    </m:d>
+                    <m:r>
+                      <m:rPr>
+                        <m:sz m:val="38"/>
+                      </m:rPr>
+                      <m:t>+</m:t>
+                    </m:r>
+                    <m:f>
+                      <m:fPr>
+                        <m:type m:val="bar"/>
+                      </m:fPr>
+                      <m:num>
+                        <m:r>
+                          <m:rPr>
+                            <m:sz m:val="38"/>
+                          </m:rPr>
+                          <m:t>4</m:t>
+                        </m:r>
+                      </m:num>
+                      <m:den>
+                        <m:r>
+                          <m:rPr>
+                            <m:sz m:val="38"/>
+                          </m:rPr>
+                          <m:t>9</m:t>
+                        </m:r>
+                      </m:den>
+                    </m:f>
+                    <m:d>
+                      <m:dPr>
+                        <m:sepChr m:val="−"/>
+                      </m:dPr>
+                      <m:e/>
+                      <m:e>
+                        <m:r>
+                          <m:rPr>
+                            <m:sty m:val="p"/>
+                            <m:sz m:val="38"/>
+                          </m:rPr>
+                          <m:t>log</m:t>
+                        </m:r>
+                        <m:f>
+                          <m:fPr>
+                            <m:type m:val="bar"/>
+                          </m:fPr>
+                          <m:num>
+                            <m:r>
+                              <m:rPr>
+                                <m:sz m:val="38"/>
+                              </m:rPr>
+                              <m:t>4</m:t>
+                            </m:r>
+                          </m:num>
+                          <m:den>
+                            <m:r>
+                              <m:rPr>
+                                <m:sz m:val="38"/>
+                              </m:rPr>
+                              <m:t>9</m:t>
+                            </m:r>
+                          </m:den>
+                        </m:f>
+                      </m:e>
+                    </m:d>
+                    <m:r>
+                      <m:rPr>
+                        <m:sz m:val="38"/>
+                      </m:rPr>
+                      <m:t>+</m:t>
+                    </m:r>
+                    <m:f>
+                      <m:fPr>
+                        <m:type m:val="bar"/>
+                      </m:fPr>
+                      <m:num>
+                        <m:r>
+                          <m:rPr>
+                            <m:sz m:val="38"/>
+                          </m:rPr>
+                          <m:t>4</m:t>
+                        </m:r>
+                      </m:num>
+                      <m:den>
+                        <m:r>
+                          <m:rPr>
+                            <m:sz m:val="38"/>
+                          </m:rPr>
+                          <m:t>9</m:t>
+                        </m:r>
+                      </m:den>
+                    </m:f>
+                    <m:d>
+                      <m:dPr>
+                        <m:sepChr m:val="−"/>
+                      </m:dPr>
+                      <m:e/>
+                      <m:e>
+                        <m:r>
+                          <m:rPr>
+                            <m:sty m:val="p"/>
+                            <m:sz m:val="38"/>
+                          </m:rPr>
+                          <m:t>log</m:t>
+                        </m:r>
+                        <m:f>
+                          <m:fPr>
+                            <m:type m:val="bar"/>
+                          </m:fPr>
+                          <m:num>
+                            <m:r>
+                              <m:rPr>
+                                <m:sz m:val="38"/>
+                              </m:rPr>
+                              <m:t>4</m:t>
+                            </m:r>
+                          </m:num>
+                          <m:den>
+                            <m:r>
+                              <m:rPr>
+                                <m:sz m:val="38"/>
+                              </m:rPr>
+                              <m:t>9</m:t>
+                            </m:r>
+                          </m:den>
+                        </m:f>
+                      </m:e>
+                    </m:d>
+                  </m:oMath>
+                </a14:m>
+              </mc:Choice>
+              <mc:Fallback>
+                <a:r>
+                  <a:t>H(X+Y)=19(−log19)+49(−log49)+49(−log49)</a:t>
+                </a:r>
+              </mc:Fallback>
+            </mc:AlternateContent>
           </a:p>
           <a:p>
             <a:pPr>
@@ -3956,24 +5249,312 @@
                 </a:solidFill>
                 <a:latin typeface="Microsoft YaHei"/>
               </a:rPr>
-              <a:t>▶ H(X, Y) 更大；且对任意 X、Y 都有 H(X, Y) ≥ H(X + Y)。原因：记 a(x, y) = P{X = x, Y = y}，b(x, y) = P{X + Y = x + y}，则对任意 x、y 有 a(x, y) ≤ b(x, y)，故</a:t>
-            </a:r>
-          </a:p>
-          <a:p>
-            <a:pPr lvl="1">
+              <a:t>▶ </a:t>
+            </a:r>
+            <mc:AlternateContent xmlns:mc="http://schemas.openxmlformats.org/markup-compatibility/2006" xmlns:a14="http://schemas.microsoft.com/office/drawing/2010/main" mc:Ignorable="a14">
+              <mc:Choice Requires="a14">
+                <a14:m>
+                  <m:oMath xmlns:m="http://schemas.openxmlformats.org/officeDocument/2006/math">
+                    <m:r>
+                      <m:rPr>
+                        <m:sz m:val="38"/>
+                      </m:rPr>
+                      <m:t>H(X,Y)</m:t>
+                    </m:r>
+                  </m:oMath>
+                </a14:m>
+              </mc:Choice>
+              <mc:Fallback>
+                <a:r>
+                  <a:t>H(X,Y)</a:t>
+                </a:r>
+              </mc:Fallback>
+            </mc:AlternateContent>
+            <a:r>
+              <a:rPr sz="1900">
+                <a:solidFill>
+                  <a:srgbClr val="202020"/>
+                </a:solidFill>
+                <a:latin typeface="Microsoft YaHei"/>
+              </a:rPr>
+              <a:t> 更大；且对任意 </a:t>
+            </a:r>
+            <mc:AlternateContent xmlns:mc="http://schemas.openxmlformats.org/markup-compatibility/2006" xmlns:a14="http://schemas.microsoft.com/office/drawing/2010/main" mc:Ignorable="a14">
+              <mc:Choice Requires="a14">
+                <a14:m>
+                  <m:oMath xmlns:m="http://schemas.openxmlformats.org/officeDocument/2006/math">
+                    <m:r>
+                      <m:rPr>
+                        <m:sz m:val="38"/>
+                      </m:rPr>
+                      <m:t>X</m:t>
+                    </m:r>
+                  </m:oMath>
+                </a14:m>
+              </mc:Choice>
+              <mc:Fallback>
+                <a:r>
+                  <a:t>X</a:t>
+                </a:r>
+              </mc:Fallback>
+            </mc:AlternateContent>
+            <a:r>
+              <a:rPr sz="1900">
+                <a:solidFill>
+                  <a:srgbClr val="202020"/>
+                </a:solidFill>
+                <a:latin typeface="Microsoft YaHei"/>
+              </a:rPr>
+              <a:t>、</a:t>
+            </a:r>
+            <mc:AlternateContent xmlns:mc="http://schemas.openxmlformats.org/markup-compatibility/2006" xmlns:a14="http://schemas.microsoft.com/office/drawing/2010/main" mc:Ignorable="a14">
+              <mc:Choice Requires="a14">
+                <a14:m>
+                  <m:oMath xmlns:m="http://schemas.openxmlformats.org/officeDocument/2006/math">
+                    <m:r>
+                      <m:rPr>
+                        <m:sz m:val="38"/>
+                      </m:rPr>
+                      <m:t>Y</m:t>
+                    </m:r>
+                  </m:oMath>
+                </a14:m>
+              </mc:Choice>
+              <mc:Fallback>
+                <a:r>
+                  <a:t>Y</a:t>
+                </a:r>
+              </mc:Fallback>
+            </mc:AlternateContent>
+            <a:r>
+              <a:rPr sz="1900">
+                <a:solidFill>
+                  <a:srgbClr val="202020"/>
+                </a:solidFill>
+                <a:latin typeface="Microsoft YaHei"/>
+              </a:rPr>
+              <a:t> 都有 </a:t>
+            </a:r>
+            <mc:AlternateContent xmlns:mc="http://schemas.openxmlformats.org/markup-compatibility/2006" xmlns:a14="http://schemas.microsoft.com/office/drawing/2010/main" mc:Ignorable="a14">
+              <mc:Choice Requires="a14">
+                <a14:m>
+                  <m:oMath xmlns:m="http://schemas.openxmlformats.org/officeDocument/2006/math">
+                    <m:r>
+                      <m:rPr>
+                        <m:sz m:val="38"/>
+                      </m:rPr>
+                      <m:t>H(X,Y)≥H(X+Y)</m:t>
+                    </m:r>
+                  </m:oMath>
+                </a14:m>
+              </mc:Choice>
+              <mc:Fallback>
+                <a:r>
+                  <a:t>H(X,Y)≥H(X+Y)</a:t>
+                </a:r>
+              </mc:Fallback>
+            </mc:AlternateContent>
+            <a:r>
+              <a:rPr sz="1900">
+                <a:solidFill>
+                  <a:srgbClr val="202020"/>
+                </a:solidFill>
+                <a:latin typeface="Microsoft YaHei"/>
+              </a:rPr>
+              <a:t>。原因：记 </a:t>
+            </a:r>
+            <mc:AlternateContent xmlns:mc="http://schemas.openxmlformats.org/markup-compatibility/2006" xmlns:a14="http://schemas.microsoft.com/office/drawing/2010/main" mc:Ignorable="a14">
+              <mc:Choice Requires="a14">
+                <a14:m>
+                  <m:oMath xmlns:m="http://schemas.openxmlformats.org/officeDocument/2006/math">
+                    <m:r>
+                      <m:rPr>
+                        <m:sz m:val="38"/>
+                      </m:rPr>
+                      <m:t>a(x,y)=P{X=x,Y=y}</m:t>
+                    </m:r>
+                  </m:oMath>
+                </a14:m>
+              </mc:Choice>
+              <mc:Fallback>
+                <a:r>
+                  <a:t>a(x,y)=P{X=x,Y=y}</a:t>
+                </a:r>
+              </mc:Fallback>
+            </mc:AlternateContent>
+            <a:r>
+              <a:rPr sz="1900">
+                <a:solidFill>
+                  <a:srgbClr val="202020"/>
+                </a:solidFill>
+                <a:latin typeface="Microsoft YaHei"/>
+              </a:rPr>
+              <a:t>，</a:t>
+            </a:r>
+            <mc:AlternateContent xmlns:mc="http://schemas.openxmlformats.org/markup-compatibility/2006" xmlns:a14="http://schemas.microsoft.com/office/drawing/2010/main" mc:Ignorable="a14">
+              <mc:Choice Requires="a14">
+                <a14:m>
+                  <m:oMath xmlns:m="http://schemas.openxmlformats.org/officeDocument/2006/math">
+                    <m:r>
+                      <m:rPr>
+                        <m:sz m:val="38"/>
+                      </m:rPr>
+                      <m:t>b(x,y)=P{X+Y=x+y}</m:t>
+                    </m:r>
+                  </m:oMath>
+                </a14:m>
+              </mc:Choice>
+              <mc:Fallback>
+                <a:r>
+                  <a:t>b(x,y)=P{X+Y=x+y}</a:t>
+                </a:r>
+              </mc:Fallback>
+            </mc:AlternateContent>
+            <a:r>
+              <a:rPr sz="1900">
+                <a:solidFill>
+                  <a:srgbClr val="202020"/>
+                </a:solidFill>
+                <a:latin typeface="Microsoft YaHei"/>
+              </a:rPr>
+              <a:t>，则对任意 </a:t>
+            </a:r>
+            <mc:AlternateContent xmlns:mc="http://schemas.openxmlformats.org/markup-compatibility/2006" xmlns:a14="http://schemas.microsoft.com/office/drawing/2010/main" mc:Ignorable="a14">
+              <mc:Choice Requires="a14">
+                <a14:m>
+                  <m:oMath xmlns:m="http://schemas.openxmlformats.org/officeDocument/2006/math">
+                    <m:r>
+                      <m:rPr>
+                        <m:sz m:val="38"/>
+                      </m:rPr>
+                      <m:t>x</m:t>
+                    </m:r>
+                  </m:oMath>
+                </a14:m>
+              </mc:Choice>
+              <mc:Fallback>
+                <a:r>
+                  <a:t>x</a:t>
+                </a:r>
+              </mc:Fallback>
+            </mc:AlternateContent>
+            <a:r>
+              <a:rPr sz="1900">
+                <a:solidFill>
+                  <a:srgbClr val="202020"/>
+                </a:solidFill>
+                <a:latin typeface="Microsoft YaHei"/>
+              </a:rPr>
+              <a:t>、</a:t>
+            </a:r>
+            <mc:AlternateContent xmlns:mc="http://schemas.openxmlformats.org/markup-compatibility/2006" xmlns:a14="http://schemas.microsoft.com/office/drawing/2010/main" mc:Ignorable="a14">
+              <mc:Choice Requires="a14">
+                <a14:m>
+                  <m:oMath xmlns:m="http://schemas.openxmlformats.org/officeDocument/2006/math">
+                    <m:r>
+                      <m:rPr>
+                        <m:sz m:val="38"/>
+                      </m:rPr>
+                      <m:t>y</m:t>
+                    </m:r>
+                  </m:oMath>
+                </a14:m>
+              </mc:Choice>
+              <mc:Fallback>
+                <a:r>
+                  <a:t>y</a:t>
+                </a:r>
+              </mc:Fallback>
+            </mc:AlternateContent>
+            <a:r>
+              <a:rPr sz="1900">
+                <a:solidFill>
+                  <a:srgbClr val="202020"/>
+                </a:solidFill>
+                <a:latin typeface="Microsoft YaHei"/>
+              </a:rPr>
+              <a:t> 有 </a:t>
+            </a:r>
+            <mc:AlternateContent xmlns:mc="http://schemas.openxmlformats.org/markup-compatibility/2006" xmlns:a14="http://schemas.microsoft.com/office/drawing/2010/main" mc:Ignorable="a14">
+              <mc:Choice Requires="a14">
+                <a14:m>
+                  <m:oMath xmlns:m="http://schemas.openxmlformats.org/officeDocument/2006/math">
+                    <m:r>
+                      <m:rPr>
+                        <m:sz m:val="38"/>
+                      </m:rPr>
+                      <m:t>a(x,y)≤b(x,y)</m:t>
+                    </m:r>
+                  </m:oMath>
+                </a14:m>
+              </mc:Choice>
+              <mc:Fallback>
+                <a:r>
+                  <a:t>a(x,y)≤b(x,y)</a:t>
+                </a:r>
+              </mc:Fallback>
+            </mc:AlternateContent>
+            <a:r>
+              <a:rPr sz="1900">
+                <a:solidFill>
+                  <a:srgbClr val="202020"/>
+                </a:solidFill>
+                <a:latin typeface="Microsoft YaHei"/>
+              </a:rPr>
+              <a:t>，故</a:t>
+            </a:r>
+          </a:p>
+          <a:p>
+            <a:pPr>
               <a:spcAft>
                 <a:spcPts val="1000"/>
               </a:spcAft>
             </a:pPr>
-            <a:r>
-              <a:rPr sz="1700">
-                <a:solidFill>
-                  <a:srgbClr val="404040"/>
-                </a:solidFill>
-                <a:latin typeface="Microsoft YaHei"/>
-              </a:rPr>
-              <a:t>H(X, Y) = E[−log a(x, y)] ≥ E[−log b(x, y)] = H(X + Y)</a:t>
-            </a:r>
+            <mc:AlternateContent xmlns:mc="http://schemas.openxmlformats.org/markup-compatibility/2006" xmlns:a14="http://schemas.microsoft.com/office/drawing/2010/main" mc:Ignorable="a14">
+              <mc:Choice Requires="a14">
+                <a14:m>
+                  <m:oMath xmlns:m="http://schemas.openxmlformats.org/officeDocument/2006/math">
+                    <m:r>
+                      <m:rPr>
+                        <m:sz m:val="38"/>
+                      </m:rPr>
+                      <m:t>H(X,Y)=E[−</m:t>
+                    </m:r>
+                    <m:r>
+                      <m:rPr>
+                        <m:sty m:val="p"/>
+                        <m:sz m:val="38"/>
+                      </m:rPr>
+                      <m:t>log</m:t>
+                    </m:r>
+                    <m:r>
+                      <m:rPr>
+                        <m:sz m:val="38"/>
+                      </m:rPr>
+                      <m:t>a(x,y)]≥E[−</m:t>
+                    </m:r>
+                    <m:r>
+                      <m:rPr>
+                        <m:sty m:val="p"/>
+                        <m:sz m:val="38"/>
+                      </m:rPr>
+                      <m:t>log</m:t>
+                    </m:r>
+                    <m:r>
+                      <m:rPr>
+                        <m:sz m:val="38"/>
+                      </m:rPr>
+                      <m:t>b(x,y)]=H(X+Y)</m:t>
+                    </m:r>
+                  </m:oMath>
+                </a14:m>
+              </mc:Choice>
+              <mc:Fallback>
+                <a:r>
+                  <a:t>H(X,Y)=E[−loga(x,y)]≥E[−logb(x,y)]=H(X+Y)</a:t>
+                </a:r>
+              </mc:Fallback>
+            </mc:AlternateContent>
           </a:p>
         </p:txBody>
       </p:sp>
@@ -4071,8 +5652,8 @@
         </p:nvSpPr>
         <p:spPr>
           <a:xfrm>
-            <a:off x="502920" y="1005840"/>
-            <a:ext cx="11155680" cy="4846320"/>
+            <a:off x="502920" y="1051560"/>
+            <a:ext cx="11155680" cy="4937760"/>
           </a:xfrm>
           <a:prstGeom prst="rect">
             <a:avLst/>
@@ -4097,7 +5678,35 @@
                 </a:solidFill>
                 <a:latin typeface="Microsoft YaHei"/>
               </a:rPr>
-              <a:t>▶ 设 X 为 [−1, 1] 上服从均匀分布的随机变量。</a:t>
+              <a:t>▶ 设 </a:t>
+            </a:r>
+            <mc:AlternateContent xmlns:mc="http://schemas.openxmlformats.org/markup-compatibility/2006" xmlns:a14="http://schemas.microsoft.com/office/drawing/2010/main" mc:Ignorable="a14">
+              <mc:Choice Requires="a14">
+                <a14:m>
+                  <m:oMath xmlns:m="http://schemas.openxmlformats.org/officeDocument/2006/math">
+                    <m:r>
+                      <m:rPr>
+                        <m:sz m:val="38"/>
+                      </m:rPr>
+                      <m:t>X</m:t>
+                    </m:r>
+                  </m:oMath>
+                </a14:m>
+              </mc:Choice>
+              <mc:Fallback>
+                <a:r>
+                  <a:t>X</a:t>
+                </a:r>
+              </mc:Fallback>
+            </mc:AlternateContent>
+            <a:r>
+              <a:rPr sz="1900">
+                <a:solidFill>
+                  <a:srgbClr val="202020"/>
+                </a:solidFill>
+                <a:latin typeface="Microsoft YaHei"/>
+              </a:rPr>
+              <a:t> 为 [−1, 1] 上服从均匀分布的随机变量。</a:t>
             </a:r>
           </a:p>
         </p:txBody>
@@ -4196,8 +5805,8 @@
         </p:nvSpPr>
         <p:spPr>
           <a:xfrm>
-            <a:off x="502920" y="1005840"/>
-            <a:ext cx="11155680" cy="4846320"/>
+            <a:off x="502920" y="1051560"/>
+            <a:ext cx="11155680" cy="4937760"/>
           </a:xfrm>
           <a:prstGeom prst="rect">
             <a:avLst/>
@@ -4222,7 +5831,35 @@
                 </a:solidFill>
                 <a:latin typeface="Microsoft YaHei"/>
               </a:rPr>
-              <a:t>▶ 设 X 为 [−1, 1] 上服从均匀分布的随机变量。</a:t>
+              <a:t>▶ 设 </a:t>
+            </a:r>
+            <mc:AlternateContent xmlns:mc="http://schemas.openxmlformats.org/markup-compatibility/2006" xmlns:a14="http://schemas.microsoft.com/office/drawing/2010/main" mc:Ignorable="a14">
+              <mc:Choice Requires="a14">
+                <a14:m>
+                  <m:oMath xmlns:m="http://schemas.openxmlformats.org/officeDocument/2006/math">
+                    <m:r>
+                      <m:rPr>
+                        <m:sz m:val="38"/>
+                      </m:rPr>
+                      <m:t>X</m:t>
+                    </m:r>
+                  </m:oMath>
+                </a14:m>
+              </mc:Choice>
+              <mc:Fallback>
+                <a:r>
+                  <a:t>X</a:t>
+                </a:r>
+              </mc:Fallback>
+            </mc:AlternateContent>
+            <a:r>
+              <a:rPr sz="1900">
+                <a:solidFill>
+                  <a:srgbClr val="202020"/>
+                </a:solidFill>
+                <a:latin typeface="Microsoft YaHei"/>
+              </a:rPr>
+              <a:t> 为 [−1, 1] 上服从均匀分布的随机变量。</a:t>
             </a:r>
           </a:p>
           <a:p>
@@ -4238,7 +5875,47 @@
                 </a:solidFill>
                 <a:latin typeface="Microsoft YaHei"/>
               </a:rPr>
-              <a:t>▶ 计算 X² 的方差。</a:t>
+              <a:t>▶ 计算 </a:t>
+            </a:r>
+            <mc:AlternateContent xmlns:mc="http://schemas.openxmlformats.org/markup-compatibility/2006" xmlns:a14="http://schemas.microsoft.com/office/drawing/2010/main" mc:Ignorable="a14">
+              <mc:Choice Requires="a14">
+                <a14:m>
+                  <m:oMath xmlns:m="http://schemas.openxmlformats.org/officeDocument/2006/math">
+                    <m:sSup>
+                      <m:e>
+                        <m:r>
+                          <m:rPr>
+                            <m:sz m:val="38"/>
+                          </m:rPr>
+                          <m:t>X</m:t>
+                        </m:r>
+                      </m:e>
+                      <m:sup>
+                        <m:r>
+                          <m:rPr>
+                            <m:sz m:val="38"/>
+                          </m:rPr>
+                          <m:t>2</m:t>
+                        </m:r>
+                      </m:sup>
+                    </m:sSup>
+                  </m:oMath>
+                </a14:m>
+              </mc:Choice>
+              <mc:Fallback>
+                <a:r>
+                  <a:t>X2</a:t>
+                </a:r>
+              </mc:Fallback>
+            </mc:AlternateContent>
+            <a:r>
+              <a:rPr sz="1900">
+                <a:solidFill>
+                  <a:srgbClr val="202020"/>
+                </a:solidFill>
+                <a:latin typeface="Microsoft YaHei"/>
+              </a:rPr>
+              <a:t> 的方差。</a:t>
             </a:r>
           </a:p>
         </p:txBody>
@@ -4337,8 +6014,8 @@
         </p:nvSpPr>
         <p:spPr>
           <a:xfrm>
-            <a:off x="502920" y="1005840"/>
-            <a:ext cx="11155680" cy="4846320"/>
+            <a:off x="502920" y="1051560"/>
+            <a:ext cx="11155680" cy="4937760"/>
           </a:xfrm>
           <a:prstGeom prst="rect">
             <a:avLst/>
@@ -4363,7 +6040,35 @@
                 </a:solidFill>
                 <a:latin typeface="Microsoft YaHei"/>
               </a:rPr>
-              <a:t>▶ 设 X 为 [−1, 1] 上服从均匀分布的随机变量。</a:t>
+              <a:t>▶ 设 </a:t>
+            </a:r>
+            <mc:AlternateContent xmlns:mc="http://schemas.openxmlformats.org/markup-compatibility/2006" xmlns:a14="http://schemas.microsoft.com/office/drawing/2010/main" mc:Ignorable="a14">
+              <mc:Choice Requires="a14">
+                <a14:m>
+                  <m:oMath xmlns:m="http://schemas.openxmlformats.org/officeDocument/2006/math">
+                    <m:r>
+                      <m:rPr>
+                        <m:sz m:val="38"/>
+                      </m:rPr>
+                      <m:t>X</m:t>
+                    </m:r>
+                  </m:oMath>
+                </a14:m>
+              </mc:Choice>
+              <mc:Fallback>
+                <a:r>
+                  <a:t>X</a:t>
+                </a:r>
+              </mc:Fallback>
+            </mc:AlternateContent>
+            <a:r>
+              <a:rPr sz="1900">
+                <a:solidFill>
+                  <a:srgbClr val="202020"/>
+                </a:solidFill>
+                <a:latin typeface="Microsoft YaHei"/>
+              </a:rPr>
+              <a:t> 为 [−1, 1] 上服从均匀分布的随机变量。</a:t>
             </a:r>
           </a:p>
           <a:p>
@@ -4379,7 +6084,47 @@
                 </a:solidFill>
                 <a:latin typeface="Microsoft YaHei"/>
               </a:rPr>
-              <a:t>▶ 计算 X² 的方差。</a:t>
+              <a:t>▶ 计算 </a:t>
+            </a:r>
+            <mc:AlternateContent xmlns:mc="http://schemas.openxmlformats.org/markup-compatibility/2006" xmlns:a14="http://schemas.microsoft.com/office/drawing/2010/main" mc:Ignorable="a14">
+              <mc:Choice Requires="a14">
+                <a14:m>
+                  <m:oMath xmlns:m="http://schemas.openxmlformats.org/officeDocument/2006/math">
+                    <m:sSup>
+                      <m:e>
+                        <m:r>
+                          <m:rPr>
+                            <m:sz m:val="38"/>
+                          </m:rPr>
+                          <m:t>X</m:t>
+                        </m:r>
+                      </m:e>
+                      <m:sup>
+                        <m:r>
+                          <m:rPr>
+                            <m:sz m:val="38"/>
+                          </m:rPr>
+                          <m:t>2</m:t>
+                        </m:r>
+                      </m:sup>
+                    </m:sSup>
+                  </m:oMath>
+                </a14:m>
+              </mc:Choice>
+              <mc:Fallback>
+                <a:r>
+                  <a:t>X2</a:t>
+                </a:r>
+              </mc:Fallback>
+            </mc:AlternateContent>
+            <a:r>
+              <a:rPr sz="1900">
+                <a:solidFill>
+                  <a:srgbClr val="202020"/>
+                </a:solidFill>
+                <a:latin typeface="Microsoft YaHei"/>
+              </a:rPr>
+              <a:t> 的方差。</a:t>
             </a:r>
           </a:p>
           <a:p>
@@ -4395,7 +6140,175 @@
                 </a:solidFill>
                 <a:latin typeface="Microsoft YaHei"/>
               </a:rPr>
-              <a:t>▶ 若 X₁, …, Xₙ 是 X 的独立副本，求其中最小者 min Xᵢ 的概率密度函数。</a:t>
+              <a:t>▶ 若 </a:t>
+            </a:r>
+            <mc:AlternateContent xmlns:mc="http://schemas.openxmlformats.org/markup-compatibility/2006" xmlns:a14="http://schemas.microsoft.com/office/drawing/2010/main" mc:Ignorable="a14">
+              <mc:Choice Requires="a14">
+                <a14:m>
+                  <m:oMath xmlns:m="http://schemas.openxmlformats.org/officeDocument/2006/math">
+                    <m:sSub>
+                      <m:e>
+                        <m:r>
+                          <m:rPr>
+                            <m:sz m:val="38"/>
+                          </m:rPr>
+                          <m:t>X</m:t>
+                        </m:r>
+                      </m:e>
+                      <m:sub>
+                        <m:r>
+                          <m:rPr>
+                            <m:sz m:val="38"/>
+                          </m:rPr>
+                          <m:t>1</m:t>
+                        </m:r>
+                      </m:sub>
+                    </m:sSub>
+                    <m:r>
+                      <m:rPr>
+                        <m:sz m:val="38"/>
+                      </m:rPr>
+                      <m:t>,…,</m:t>
+                    </m:r>
+                    <m:sSub>
+                      <m:e>
+                        <m:r>
+                          <m:rPr>
+                            <m:sz m:val="38"/>
+                          </m:rPr>
+                          <m:t>X</m:t>
+                        </m:r>
+                      </m:e>
+                      <m:sub>
+                        <m:r>
+                          <m:rPr>
+                            <m:sz m:val="38"/>
+                          </m:rPr>
+                          <m:t>n</m:t>
+                        </m:r>
+                      </m:sub>
+                    </m:sSub>
+                  </m:oMath>
+                </a14:m>
+              </mc:Choice>
+              <mc:Fallback>
+                <a:r>
+                  <a:t>X1,…,Xn</a:t>
+                </a:r>
+              </mc:Fallback>
+            </mc:AlternateContent>
+            <a:r>
+              <a:rPr sz="1900">
+                <a:solidFill>
+                  <a:srgbClr val="202020"/>
+                </a:solidFill>
+                <a:latin typeface="Microsoft YaHei"/>
+              </a:rPr>
+              <a:t> 是 </a:t>
+            </a:r>
+            <mc:AlternateContent xmlns:mc="http://schemas.openxmlformats.org/markup-compatibility/2006" xmlns:a14="http://schemas.microsoft.com/office/drawing/2010/main" mc:Ignorable="a14">
+              <mc:Choice Requires="a14">
+                <a14:m>
+                  <m:oMath xmlns:m="http://schemas.openxmlformats.org/officeDocument/2006/math">
+                    <m:r>
+                      <m:rPr>
+                        <m:sz m:val="38"/>
+                      </m:rPr>
+                      <m:t>X</m:t>
+                    </m:r>
+                  </m:oMath>
+                </a14:m>
+              </mc:Choice>
+              <mc:Fallback>
+                <a:r>
+                  <a:t>X</a:t>
+                </a:r>
+              </mc:Fallback>
+            </mc:AlternateContent>
+            <a:r>
+              <a:rPr sz="1900">
+                <a:solidFill>
+                  <a:srgbClr val="202020"/>
+                </a:solidFill>
+                <a:latin typeface="Microsoft YaHei"/>
+              </a:rPr>
+              <a:t> 的独立副本，求其中最小者 </a:t>
+            </a:r>
+            <mc:AlternateContent xmlns:mc="http://schemas.openxmlformats.org/markup-compatibility/2006" xmlns:a14="http://schemas.microsoft.com/office/drawing/2010/main" mc:Ignorable="a14">
+              <mc:Choice Requires="a14">
+                <a14:m>
+                  <m:oMath xmlns:m="http://schemas.openxmlformats.org/officeDocument/2006/math">
+                    <m:r>
+                      <m:rPr>
+                        <m:sz m:val="38"/>
+                      </m:rPr>
+                      <m:t>min{</m:t>
+                    </m:r>
+                    <m:sSub>
+                      <m:e>
+                        <m:r>
+                          <m:rPr>
+                            <m:sz m:val="38"/>
+                          </m:rPr>
+                          <m:t>X</m:t>
+                        </m:r>
+                      </m:e>
+                      <m:sub>
+                        <m:r>
+                          <m:rPr>
+                            <m:sz m:val="38"/>
+                          </m:rPr>
+                          <m:t>1</m:t>
+                        </m:r>
+                      </m:sub>
+                    </m:sSub>
+                    <m:r>
+                      <m:rPr>
+                        <m:sz m:val="38"/>
+                      </m:rPr>
+                      <m:t>,…,</m:t>
+                    </m:r>
+                    <m:sSub>
+                      <m:e>
+                        <m:r>
+                          <m:rPr>
+                            <m:sz m:val="38"/>
+                          </m:rPr>
+                          <m:t>X</m:t>
+                        </m:r>
+                      </m:e>
+                      <m:sub>
+                        <m:r>
+                          <m:rPr>
+                            <m:sz m:val="38"/>
+                          </m:rPr>
+                          <m:t>n</m:t>
+                        </m:r>
+                      </m:sub>
+                    </m:sSub>
+                    <m:r>
+                      <m:rPr>
+                        <m:sz m:val="38"/>
+                      </m:rPr>
+                      <m:t>}</m:t>
+                    </m:r>
+                  </m:oMath>
+                </a14:m>
+              </mc:Choice>
+              <mc:Fallback>
+                <a:r>
+                  <a:t>min{X1,…,Xn}</a:t>
+                </a:r>
+              </mc:Fallback>
+            </mc:AlternateContent>
+            <a:r>
+              <a:rPr sz="1900">
+                <a:solidFill>
+                  <a:srgbClr val="202020"/>
+                </a:solidFill>
+                <a:latin typeface="Microsoft YaHei"/>
+              </a:rPr>
+              <a:t> 的概率密度函数。</a:t>
             </a:r>
           </a:p>
         </p:txBody>
@@ -4494,8 +6407,8 @@
         </p:nvSpPr>
         <p:spPr>
           <a:xfrm>
-            <a:off x="502920" y="1005840"/>
-            <a:ext cx="11155680" cy="4846320"/>
+            <a:off x="502920" y="1051560"/>
+            <a:ext cx="11155680" cy="4937760"/>
           </a:xfrm>
           <a:prstGeom prst="rect">
             <a:avLst/>
@@ -4520,24 +6433,403 @@
                 </a:solidFill>
                 <a:latin typeface="Microsoft YaHei"/>
               </a:rPr>
-              <a:t>▶ Var[X²] = E[X⁴] − (E[X²])²</a:t>
-            </a:r>
-          </a:p>
-          <a:p>
-            <a:pPr lvl="1">
+              <a:t>▶ </a:t>
+            </a:r>
+            <mc:AlternateContent xmlns:mc="http://schemas.openxmlformats.org/markup-compatibility/2006" xmlns:a14="http://schemas.microsoft.com/office/drawing/2010/main" mc:Ignorable="a14">
+              <mc:Choice Requires="a14">
+                <a14:m>
+                  <m:oMath xmlns:m="http://schemas.openxmlformats.org/officeDocument/2006/math">
+                    <m:r>
+                      <m:rPr>
+                        <m:sty m:val="p"/>
+                        <m:sz m:val="38"/>
+                      </m:rPr>
+                      <m:t>Var</m:t>
+                    </m:r>
+                    <m:r>
+                      <m:rPr>
+                        <m:sz m:val="38"/>
+                      </m:rPr>
+                      <m:t>[</m:t>
+                    </m:r>
+                    <m:sSup>
+                      <m:e>
+                        <m:r>
+                          <m:rPr>
+                            <m:sz m:val="38"/>
+                          </m:rPr>
+                          <m:t>X</m:t>
+                        </m:r>
+                      </m:e>
+                      <m:sup>
+                        <m:r>
+                          <m:rPr>
+                            <m:sz m:val="38"/>
+                          </m:rPr>
+                          <m:t>2</m:t>
+                        </m:r>
+                      </m:sup>
+                    </m:sSup>
+                    <m:r>
+                      <m:rPr>
+                        <m:sz m:val="38"/>
+                      </m:rPr>
+                      <m:t>]=E[</m:t>
+                    </m:r>
+                    <m:sSup>
+                      <m:e>
+                        <m:r>
+                          <m:rPr>
+                            <m:sz m:val="38"/>
+                          </m:rPr>
+                          <m:t>X</m:t>
+                        </m:r>
+                      </m:e>
+                      <m:sup>
+                        <m:r>
+                          <m:rPr>
+                            <m:sz m:val="38"/>
+                          </m:rPr>
+                          <m:t>4</m:t>
+                        </m:r>
+                      </m:sup>
+                    </m:sSup>
+                    <m:r>
+                      <m:rPr>
+                        <m:sz m:val="38"/>
+                      </m:rPr>
+                      <m:t>]−(E[</m:t>
+                    </m:r>
+                    <m:sSup>
+                      <m:e>
+                        <m:r>
+                          <m:rPr>
+                            <m:sz m:val="38"/>
+                          </m:rPr>
+                          <m:t>X</m:t>
+                        </m:r>
+                      </m:e>
+                      <m:sup>
+                        <m:r>
+                          <m:rPr>
+                            <m:sz m:val="38"/>
+                          </m:rPr>
+                          <m:t>2</m:t>
+                        </m:r>
+                      </m:sup>
+                    </m:sSup>
+                    <m:r>
+                      <m:rPr>
+                        <m:sz m:val="38"/>
+                      </m:rPr>
+                      <m:t>]</m:t>
+                    </m:r>
+                    <m:sSup>
+                      <m:e>
+                        <m:r>
+                          <m:rPr>
+                            <m:sz m:val="38"/>
+                          </m:rPr>
+                          <m:t>)</m:t>
+                        </m:r>
+                      </m:e>
+                      <m:sup>
+                        <m:r>
+                          <m:rPr>
+                            <m:sz m:val="38"/>
+                          </m:rPr>
+                          <m:t>2</m:t>
+                        </m:r>
+                      </m:sup>
+                    </m:sSup>
+                  </m:oMath>
+                </a14:m>
+              </mc:Choice>
+              <mc:Fallback>
+                <a:r>
+                  <a:t>Var[X2]=E[X4]−(E[X2])2</a:t>
+                </a:r>
+              </mc:Fallback>
+            </mc:AlternateContent>
+          </a:p>
+          <a:p>
+            <a:pPr>
               <a:spcAft>
                 <a:spcPts val="1000"/>
               </a:spcAft>
             </a:pPr>
             <a:r>
-              <a:rPr sz="1700">
-                <a:solidFill>
-                  <a:srgbClr val="404040"/>
-                </a:solidFill>
-                <a:latin typeface="Microsoft YaHei"/>
-              </a:rPr>
-              <a:t>= ∫₋₁¹ ½x⁴ dx − (∫₋₁¹ ½x² dx)² = 1/5 − 1/9 = 4/45</a:t>
-            </a:r>
+              <a:rPr sz="1900">
+                <a:solidFill>
+                  <a:srgbClr val="202020"/>
+                </a:solidFill>
+                <a:latin typeface="Microsoft YaHei"/>
+              </a:rPr>
+              <a:t>= </a:t>
+            </a:r>
+            <mc:AlternateContent xmlns:mc="http://schemas.openxmlformats.org/markup-compatibility/2006" xmlns:a14="http://schemas.microsoft.com/office/drawing/2010/main" mc:Ignorable="a14">
+              <mc:Choice Requires="a14">
+                <a14:m>
+                  <m:oMath xmlns:m="http://schemas.openxmlformats.org/officeDocument/2006/math">
+                    <m:nary>
+                      <m:naryPr>
+                        <m:chr m:val="∫"/>
+                        <m:limLoc m:val="subSup"/>
+                        <m:grow m:val="1"/>
+                        <m:subHide m:val="off"/>
+                        <m:supHide m:val="off"/>
+                      </m:naryPr>
+                      <m:sub>
+                        <m:r>
+                          <m:rPr>
+                            <m:sz m:val="38"/>
+                          </m:rPr>
+                          <m:t>−1</m:t>
+                        </m:r>
+                      </m:sub>
+                      <m:sup>
+                        <m:r>
+                          <m:rPr>
+                            <m:sz m:val="38"/>
+                          </m:rPr>
+                          <m:t>1</m:t>
+                        </m:r>
+                      </m:sup>
+                      <m:e>
+                        <m:f>
+                          <m:fPr>
+                            <m:type m:val="bar"/>
+                          </m:fPr>
+                          <m:num>
+                            <m:r>
+                              <m:rPr>
+                                <m:sz m:val="38"/>
+                              </m:rPr>
+                              <m:t>1</m:t>
+                            </m:r>
+                          </m:num>
+                          <m:den>
+                            <m:r>
+                              <m:rPr>
+                                <m:sz m:val="38"/>
+                              </m:rPr>
+                              <m:t>2</m:t>
+                            </m:r>
+                          </m:den>
+                        </m:f>
+                      </m:e>
+                    </m:nary>
+                    <m:sSup>
+                      <m:e>
+                        <m:r>
+                          <m:rPr>
+                            <m:sz m:val="38"/>
+                          </m:rPr>
+                          <m:t>x</m:t>
+                        </m:r>
+                      </m:e>
+                      <m:sup>
+                        <m:r>
+                          <m:rPr>
+                            <m:sz m:val="38"/>
+                          </m:rPr>
+                          <m:t>4</m:t>
+                        </m:r>
+                      </m:sup>
+                    </m:sSup>
+                    <m:r>
+                      <m:rPr>
+                        <m:sz m:val="38"/>
+                      </m:rPr>
+                      <m:t>dx−</m:t>
+                    </m:r>
+                    <m:sSup>
+                      <m:e>
+                        <m:d>
+                          <m:dPr>
+                            <m:sepChr m:val=""/>
+                          </m:dPr>
+                          <m:e>
+                            <m:nary>
+                              <m:naryPr>
+                                <m:chr m:val="∫"/>
+                                <m:limLoc m:val="subSup"/>
+                                <m:grow m:val="1"/>
+                                <m:subHide m:val="off"/>
+                                <m:supHide m:val="off"/>
+                              </m:naryPr>
+                              <m:sub>
+                                <m:r>
+                                  <m:rPr>
+                                    <m:sz m:val="38"/>
+                                  </m:rPr>
+                                  <m:t>−1</m:t>
+                                </m:r>
+                              </m:sub>
+                              <m:sup>
+                                <m:r>
+                                  <m:rPr>
+                                    <m:sz m:val="38"/>
+                                  </m:rPr>
+                                  <m:t>1</m:t>
+                                </m:r>
+                              </m:sup>
+                              <m:e>
+                                <m:f>
+                                  <m:fPr>
+                                    <m:type m:val="bar"/>
+                                  </m:fPr>
+                                  <m:num>
+                                    <m:r>
+                                      <m:rPr>
+                                        <m:sz m:val="38"/>
+                                      </m:rPr>
+                                      <m:t>1</m:t>
+                                    </m:r>
+                                  </m:num>
+                                  <m:den>
+                                    <m:r>
+                                      <m:rPr>
+                                        <m:sz m:val="38"/>
+                                      </m:rPr>
+                                      <m:t>2</m:t>
+                                    </m:r>
+                                  </m:den>
+                                </m:f>
+                              </m:e>
+                            </m:nary>
+                            <m:sSup>
+                              <m:e>
+                                <m:r>
+                                  <m:rPr>
+                                    <m:sz m:val="38"/>
+                                  </m:rPr>
+                                  <m:t>x</m:t>
+                                </m:r>
+                              </m:e>
+                              <m:sup>
+                                <m:r>
+                                  <m:rPr>
+                                    <m:sz m:val="38"/>
+                                  </m:rPr>
+                                  <m:t>2</m:t>
+                                </m:r>
+                              </m:sup>
+                            </m:sSup>
+                            <m:r>
+                              <m:rPr>
+                                <m:sz m:val="38"/>
+                              </m:rPr>
+                              <m:t>d</m:t>
+                            </m:r>
+                            <m:r>
+                              <m:rPr>
+                                <m:sz m:val="38"/>
+                              </m:rPr>
+                              <m:t>x</m:t>
+                            </m:r>
+                          </m:e>
+                        </m:d>
+                      </m:e>
+                      <m:sup>
+                        <m:r>
+                          <m:rPr>
+                            <m:sz m:val="38"/>
+                          </m:rPr>
+                          <m:t>2</m:t>
+                        </m:r>
+                      </m:sup>
+                    </m:sSup>
+                    <m:r>
+                      <m:rPr>
+                        <m:sz m:val="38"/>
+                      </m:rPr>
+                      <m:t>=</m:t>
+                    </m:r>
+                    <m:f>
+                      <m:fPr>
+                        <m:type m:val="bar"/>
+                      </m:fPr>
+                      <m:num>
+                        <m:r>
+                          <m:rPr>
+                            <m:sz m:val="38"/>
+                          </m:rPr>
+                          <m:t>1</m:t>
+                        </m:r>
+                      </m:num>
+                      <m:den>
+                        <m:r>
+                          <m:rPr>
+                            <m:sz m:val="38"/>
+                          </m:rPr>
+                          <m:t>5</m:t>
+                        </m:r>
+                      </m:den>
+                    </m:f>
+                    <m:r>
+                      <m:rPr>
+                        <m:sz m:val="38"/>
+                      </m:rPr>
+                      <m:t>−</m:t>
+                    </m:r>
+                    <m:f>
+                      <m:fPr>
+                        <m:type m:val="bar"/>
+                      </m:fPr>
+                      <m:num>
+                        <m:r>
+                          <m:rPr>
+                            <m:sz m:val="38"/>
+                          </m:rPr>
+                          <m:t>1</m:t>
+                        </m:r>
+                      </m:num>
+                      <m:den>
+                        <m:r>
+                          <m:rPr>
+                            <m:sz m:val="38"/>
+                          </m:rPr>
+                          <m:t>9</m:t>
+                        </m:r>
+                      </m:den>
+                    </m:f>
+                    <m:r>
+                      <m:rPr>
+                        <m:sz m:val="38"/>
+                      </m:rPr>
+                      <m:t>=</m:t>
+                    </m:r>
+                    <m:f>
+                      <m:fPr>
+                        <m:type m:val="bar"/>
+                      </m:fPr>
+                      <m:num>
+                        <m:r>
+                          <m:rPr>
+                            <m:sz m:val="38"/>
+                          </m:rPr>
+                          <m:t>4</m:t>
+                        </m:r>
+                      </m:num>
+                      <m:den>
+                        <m:r>
+                          <m:rPr>
+                            <m:sz m:val="38"/>
+                          </m:rPr>
+                          <m:t>45</m:t>
+                        </m:r>
+                      </m:den>
+                    </m:f>
+                  </m:oMath>
+                </a14:m>
+              </mc:Choice>
+              <mc:Fallback>
+                <a:r>
+                  <a:t>∫−1112x4dx−(∫−1112x2dx)2=15−19=445</a:t>
+                </a:r>
+              </mc:Fallback>
+            </mc:AlternateContent>
           </a:p>
         </p:txBody>
       </p:sp>
@@ -4635,8 +6927,8 @@
         </p:nvSpPr>
         <p:spPr>
           <a:xfrm>
-            <a:off x="502920" y="1005840"/>
-            <a:ext cx="11155680" cy="4846320"/>
+            <a:off x="502920" y="1051560"/>
+            <a:ext cx="11155680" cy="4937760"/>
           </a:xfrm>
           <a:prstGeom prst="rect">
             <a:avLst/>
@@ -4661,8 +6953,380 @@
                 </a:solidFill>
                 <a:latin typeface="Microsoft YaHei"/>
               </a:rPr>
-              <a:t>▶ Var[X²] = E[X⁴] − (E[X²])² = ∫₋₁¹ ½x⁴ dx − (∫₋₁¹ ½x² dx)² = 1/5 − 1/9 = 4/45</a:t>
-            </a:r>
+              <a:t>▶ </a:t>
+            </a:r>
+            <mc:AlternateContent xmlns:mc="http://schemas.openxmlformats.org/markup-compatibility/2006" xmlns:a14="http://schemas.microsoft.com/office/drawing/2010/main" mc:Ignorable="a14">
+              <mc:Choice Requires="a14">
+                <a14:m>
+                  <m:oMath xmlns:m="http://schemas.openxmlformats.org/officeDocument/2006/math">
+                    <m:r>
+                      <m:rPr>
+                        <m:sty m:val="p"/>
+                        <m:sz m:val="38"/>
+                      </m:rPr>
+                      <m:t>Var</m:t>
+                    </m:r>
+                    <m:r>
+                      <m:rPr>
+                        <m:sz m:val="38"/>
+                      </m:rPr>
+                      <m:t>[</m:t>
+                    </m:r>
+                    <m:sSup>
+                      <m:e>
+                        <m:r>
+                          <m:rPr>
+                            <m:sz m:val="38"/>
+                          </m:rPr>
+                          <m:t>X</m:t>
+                        </m:r>
+                      </m:e>
+                      <m:sup>
+                        <m:r>
+                          <m:rPr>
+                            <m:sz m:val="38"/>
+                          </m:rPr>
+                          <m:t>2</m:t>
+                        </m:r>
+                      </m:sup>
+                    </m:sSup>
+                    <m:r>
+                      <m:rPr>
+                        <m:sz m:val="38"/>
+                      </m:rPr>
+                      <m:t>]=E[</m:t>
+                    </m:r>
+                    <m:sSup>
+                      <m:e>
+                        <m:r>
+                          <m:rPr>
+                            <m:sz m:val="38"/>
+                          </m:rPr>
+                          <m:t>X</m:t>
+                        </m:r>
+                      </m:e>
+                      <m:sup>
+                        <m:r>
+                          <m:rPr>
+                            <m:sz m:val="38"/>
+                          </m:rPr>
+                          <m:t>4</m:t>
+                        </m:r>
+                      </m:sup>
+                    </m:sSup>
+                    <m:r>
+                      <m:rPr>
+                        <m:sz m:val="38"/>
+                      </m:rPr>
+                      <m:t>]−(E[</m:t>
+                    </m:r>
+                    <m:sSup>
+                      <m:e>
+                        <m:r>
+                          <m:rPr>
+                            <m:sz m:val="38"/>
+                          </m:rPr>
+                          <m:t>X</m:t>
+                        </m:r>
+                      </m:e>
+                      <m:sup>
+                        <m:r>
+                          <m:rPr>
+                            <m:sz m:val="38"/>
+                          </m:rPr>
+                          <m:t>2</m:t>
+                        </m:r>
+                      </m:sup>
+                    </m:sSup>
+                    <m:r>
+                      <m:rPr>
+                        <m:sz m:val="38"/>
+                      </m:rPr>
+                      <m:t>]</m:t>
+                    </m:r>
+                    <m:sSup>
+                      <m:e>
+                        <m:r>
+                          <m:rPr>
+                            <m:sz m:val="38"/>
+                          </m:rPr>
+                          <m:t>)</m:t>
+                        </m:r>
+                      </m:e>
+                      <m:sup>
+                        <m:r>
+                          <m:rPr>
+                            <m:sz m:val="38"/>
+                          </m:rPr>
+                          <m:t>2</m:t>
+                        </m:r>
+                      </m:sup>
+                    </m:sSup>
+                    <m:r>
+                      <m:rPr>
+                        <m:sz m:val="38"/>
+                      </m:rPr>
+                      <m:t>=</m:t>
+                    </m:r>
+                    <m:nary>
+                      <m:naryPr>
+                        <m:chr m:val="∫"/>
+                        <m:limLoc m:val="subSup"/>
+                        <m:grow m:val="1"/>
+                        <m:subHide m:val="off"/>
+                        <m:supHide m:val="off"/>
+                      </m:naryPr>
+                      <m:sub>
+                        <m:r>
+                          <m:rPr>
+                            <m:sz m:val="38"/>
+                          </m:rPr>
+                          <m:t>−1</m:t>
+                        </m:r>
+                      </m:sub>
+                      <m:sup>
+                        <m:r>
+                          <m:rPr>
+                            <m:sz m:val="38"/>
+                          </m:rPr>
+                          <m:t>1</m:t>
+                        </m:r>
+                      </m:sup>
+                      <m:e>
+                        <m:f>
+                          <m:fPr>
+                            <m:type m:val="bar"/>
+                          </m:fPr>
+                          <m:num>
+                            <m:r>
+                              <m:rPr>
+                                <m:sz m:val="38"/>
+                              </m:rPr>
+                              <m:t>1</m:t>
+                            </m:r>
+                          </m:num>
+                          <m:den>
+                            <m:r>
+                              <m:rPr>
+                                <m:sz m:val="38"/>
+                              </m:rPr>
+                              <m:t>2</m:t>
+                            </m:r>
+                          </m:den>
+                        </m:f>
+                      </m:e>
+                    </m:nary>
+                    <m:sSup>
+                      <m:e>
+                        <m:r>
+                          <m:rPr>
+                            <m:sz m:val="38"/>
+                          </m:rPr>
+                          <m:t>x</m:t>
+                        </m:r>
+                      </m:e>
+                      <m:sup>
+                        <m:r>
+                          <m:rPr>
+                            <m:sz m:val="38"/>
+                          </m:rPr>
+                          <m:t>4</m:t>
+                        </m:r>
+                      </m:sup>
+                    </m:sSup>
+                    <m:r>
+                      <m:rPr>
+                        <m:sz m:val="38"/>
+                      </m:rPr>
+                      <m:t>dx−</m:t>
+                    </m:r>
+                    <m:sSup>
+                      <m:e>
+                        <m:d>
+                          <m:dPr>
+                            <m:sepChr m:val=""/>
+                          </m:dPr>
+                          <m:e>
+                            <m:nary>
+                              <m:naryPr>
+                                <m:chr m:val="∫"/>
+                                <m:limLoc m:val="subSup"/>
+                                <m:grow m:val="1"/>
+                                <m:subHide m:val="off"/>
+                                <m:supHide m:val="off"/>
+                              </m:naryPr>
+                              <m:sub>
+                                <m:r>
+                                  <m:rPr>
+                                    <m:sz m:val="38"/>
+                                  </m:rPr>
+                                  <m:t>−1</m:t>
+                                </m:r>
+                              </m:sub>
+                              <m:sup>
+                                <m:r>
+                                  <m:rPr>
+                                    <m:sz m:val="38"/>
+                                  </m:rPr>
+                                  <m:t>1</m:t>
+                                </m:r>
+                              </m:sup>
+                              <m:e>
+                                <m:f>
+                                  <m:fPr>
+                                    <m:type m:val="bar"/>
+                                  </m:fPr>
+                                  <m:num>
+                                    <m:r>
+                                      <m:rPr>
+                                        <m:sz m:val="38"/>
+                                      </m:rPr>
+                                      <m:t>1</m:t>
+                                    </m:r>
+                                  </m:num>
+                                  <m:den>
+                                    <m:r>
+                                      <m:rPr>
+                                        <m:sz m:val="38"/>
+                                      </m:rPr>
+                                      <m:t>2</m:t>
+                                    </m:r>
+                                  </m:den>
+                                </m:f>
+                              </m:e>
+                            </m:nary>
+                            <m:sSup>
+                              <m:e>
+                                <m:r>
+                                  <m:rPr>
+                                    <m:sz m:val="38"/>
+                                  </m:rPr>
+                                  <m:t>x</m:t>
+                                </m:r>
+                              </m:e>
+                              <m:sup>
+                                <m:r>
+                                  <m:rPr>
+                                    <m:sz m:val="38"/>
+                                  </m:rPr>
+                                  <m:t>2</m:t>
+                                </m:r>
+                              </m:sup>
+                            </m:sSup>
+                            <m:r>
+                              <m:rPr>
+                                <m:sz m:val="38"/>
+                              </m:rPr>
+                              <m:t>d</m:t>
+                            </m:r>
+                            <m:r>
+                              <m:rPr>
+                                <m:sz m:val="38"/>
+                              </m:rPr>
+                              <m:t>x</m:t>
+                            </m:r>
+                          </m:e>
+                        </m:d>
+                      </m:e>
+                      <m:sup>
+                        <m:r>
+                          <m:rPr>
+                            <m:sz m:val="38"/>
+                          </m:rPr>
+                          <m:t>2</m:t>
+                        </m:r>
+                      </m:sup>
+                    </m:sSup>
+                    <m:r>
+                      <m:rPr>
+                        <m:sz m:val="38"/>
+                      </m:rPr>
+                      <m:t>=</m:t>
+                    </m:r>
+                    <m:f>
+                      <m:fPr>
+                        <m:type m:val="bar"/>
+                      </m:fPr>
+                      <m:num>
+                        <m:r>
+                          <m:rPr>
+                            <m:sz m:val="38"/>
+                          </m:rPr>
+                          <m:t>1</m:t>
+                        </m:r>
+                      </m:num>
+                      <m:den>
+                        <m:r>
+                          <m:rPr>
+                            <m:sz m:val="38"/>
+                          </m:rPr>
+                          <m:t>5</m:t>
+                        </m:r>
+                      </m:den>
+                    </m:f>
+                    <m:r>
+                      <m:rPr>
+                        <m:sz m:val="38"/>
+                      </m:rPr>
+                      <m:t>−</m:t>
+                    </m:r>
+                    <m:f>
+                      <m:fPr>
+                        <m:type m:val="bar"/>
+                      </m:fPr>
+                      <m:num>
+                        <m:r>
+                          <m:rPr>
+                            <m:sz m:val="38"/>
+                          </m:rPr>
+                          <m:t>1</m:t>
+                        </m:r>
+                      </m:num>
+                      <m:den>
+                        <m:r>
+                          <m:rPr>
+                            <m:sz m:val="38"/>
+                          </m:rPr>
+                          <m:t>9</m:t>
+                        </m:r>
+                      </m:den>
+                    </m:f>
+                    <m:r>
+                      <m:rPr>
+                        <m:sz m:val="38"/>
+                      </m:rPr>
+                      <m:t>=</m:t>
+                    </m:r>
+                    <m:f>
+                      <m:fPr>
+                        <m:type m:val="bar"/>
+                      </m:fPr>
+                      <m:num>
+                        <m:r>
+                          <m:rPr>
+                            <m:sz m:val="38"/>
+                          </m:rPr>
+                          <m:t>4</m:t>
+                        </m:r>
+                      </m:num>
+                      <m:den>
+                        <m:r>
+                          <m:rPr>
+                            <m:sz m:val="38"/>
+                          </m:rPr>
+                          <m:t>45</m:t>
+                        </m:r>
+                      </m:den>
+                    </m:f>
+                  </m:oMath>
+                </a14:m>
+              </mc:Choice>
+              <mc:Fallback>
+                <a:r>
+                  <a:t>Var[X2]=E[X4]−(E[X2])2=∫−1112x4dx−(∫−1112x2dx)2=15−19=445</a:t>
+                </a:r>
+              </mc:Fallback>
+            </mc:AlternateContent>
           </a:p>
           <a:p>
             <a:pPr>
@@ -4677,8 +7341,130 @@
                 </a:solidFill>
                 <a:latin typeface="Microsoft YaHei"/>
               </a:rPr>
-              <a:t>▶ 注意：对 x ∈ [−1, 1]，有 P{X &gt; x} = ∫ₓ¹ ½ dx = (1 − x)/2。</a:t>
-            </a:r>
+              <a:t>▶ 注意：对 </a:t>
+            </a:r>
+            <mc:AlternateContent xmlns:mc="http://schemas.openxmlformats.org/markup-compatibility/2006" xmlns:a14="http://schemas.microsoft.com/office/drawing/2010/main" mc:Ignorable="a14">
+              <mc:Choice Requires="a14">
+                <a14:m>
+                  <m:oMath xmlns:m="http://schemas.openxmlformats.org/officeDocument/2006/math">
+                    <m:r>
+                      <m:rPr>
+                        <m:sz m:val="38"/>
+                      </m:rPr>
+                      <m:t>x∈[−1,1]</m:t>
+                    </m:r>
+                  </m:oMath>
+                </a14:m>
+              </mc:Choice>
+              <mc:Fallback>
+                <a:r>
+                  <a:t>x∈[−1,1]</a:t>
+                </a:r>
+              </mc:Fallback>
+            </mc:AlternateContent>
+            <a:r>
+              <a:rPr sz="1900">
+                <a:solidFill>
+                  <a:srgbClr val="202020"/>
+                </a:solidFill>
+                <a:latin typeface="Microsoft YaHei"/>
+              </a:rPr>
+              <a:t>，有 </a:t>
+            </a:r>
+            <mc:AlternateContent xmlns:mc="http://schemas.openxmlformats.org/markup-compatibility/2006" xmlns:a14="http://schemas.microsoft.com/office/drawing/2010/main" mc:Ignorable="a14">
+              <mc:Choice Requires="a14">
+                <a14:m>
+                  <m:oMath xmlns:m="http://schemas.openxmlformats.org/officeDocument/2006/math">
+                    <m:r>
+                      <m:rPr>
+                        <m:sz m:val="38"/>
+                      </m:rPr>
+                      <m:t>P{X&gt;x}=</m:t>
+                    </m:r>
+                    <m:nary>
+                      <m:naryPr>
+                        <m:chr m:val="∫"/>
+                        <m:limLoc m:val="subSup"/>
+                        <m:grow m:val="1"/>
+                        <m:subHide m:val="off"/>
+                        <m:supHide m:val="off"/>
+                      </m:naryPr>
+                      <m:sub>
+                        <m:r>
+                          <m:rPr>
+                            <m:sz m:val="38"/>
+                          </m:rPr>
+                          <m:t>x</m:t>
+                        </m:r>
+                      </m:sub>
+                      <m:sup>
+                        <m:r>
+                          <m:rPr>
+                            <m:sz m:val="38"/>
+                          </m:rPr>
+                          <m:t>1</m:t>
+                        </m:r>
+                      </m:sup>
+                      <m:e>
+                        <m:f>
+                          <m:fPr>
+                            <m:type m:val="bar"/>
+                          </m:fPr>
+                          <m:num>
+                            <m:r>
+                              <m:rPr>
+                                <m:sz m:val="38"/>
+                              </m:rPr>
+                              <m:t>1</m:t>
+                            </m:r>
+                          </m:num>
+                          <m:den>
+                            <m:r>
+                              <m:rPr>
+                                <m:sz m:val="38"/>
+                              </m:rPr>
+                              <m:t>2</m:t>
+                            </m:r>
+                          </m:den>
+                        </m:f>
+                      </m:e>
+                    </m:nary>
+                    <m:r>
+                      <m:rPr>
+                        <m:sz m:val="38"/>
+                      </m:rPr>
+                      <m:t>dx=</m:t>
+                    </m:r>
+                    <m:f>
+                      <m:fPr>
+                        <m:type m:val="bar"/>
+                      </m:fPr>
+                      <m:num>
+                        <m:r>
+                          <m:rPr>
+                            <m:sz m:val="38"/>
+                          </m:rPr>
+                          <m:t>1−x</m:t>
+                        </m:r>
+                      </m:num>
+                      <m:den>
+                        <m:r>
+                          <m:rPr>
+                            <m:sz m:val="38"/>
+                          </m:rPr>
+                          <m:t>2</m:t>
+                        </m:r>
+                      </m:den>
+                    </m:f>
+                  </m:oMath>
+                </a14:m>
+              </mc:Choice>
+              <mc:Fallback>
+                <a:r>
+                  <a:t>P{X&gt;x}=∫x112dx=1−x2</a:t>
+                </a:r>
+              </mc:Fallback>
+            </mc:AlternateContent>
           </a:p>
           <a:p>
             <a:pPr>
@@ -4693,8 +7479,215 @@
                 </a:solidFill>
                 <a:latin typeface="Microsoft YaHei"/>
               </a:rPr>
-              <a:t>▶ 若 x ∈ [−1, 1]，则 P{min{X₁, …, Xₙ} &gt; x} = P{X₁ &gt; x, X₂ &gt; x, …, Xₙ &gt; x} = ((1 − x)/2)ⁿ。</a:t>
-            </a:r>
+              <a:t>▶ 若 </a:t>
+            </a:r>
+            <mc:AlternateContent xmlns:mc="http://schemas.openxmlformats.org/markup-compatibility/2006" xmlns:a14="http://schemas.microsoft.com/office/drawing/2010/main" mc:Ignorable="a14">
+              <mc:Choice Requires="a14">
+                <a14:m>
+                  <m:oMath xmlns:m="http://schemas.openxmlformats.org/officeDocument/2006/math">
+                    <m:r>
+                      <m:rPr>
+                        <m:sz m:val="38"/>
+                      </m:rPr>
+                      <m:t>x∈[−1,1]</m:t>
+                    </m:r>
+                  </m:oMath>
+                </a14:m>
+              </mc:Choice>
+              <mc:Fallback>
+                <a:r>
+                  <a:t>x∈[−1,1]</a:t>
+                </a:r>
+              </mc:Fallback>
+            </mc:AlternateContent>
+            <a:r>
+              <a:rPr sz="1900">
+                <a:solidFill>
+                  <a:srgbClr val="202020"/>
+                </a:solidFill>
+                <a:latin typeface="Microsoft YaHei"/>
+              </a:rPr>
+              <a:t>，则 </a:t>
+            </a:r>
+            <mc:AlternateContent xmlns:mc="http://schemas.openxmlformats.org/markup-compatibility/2006" xmlns:a14="http://schemas.microsoft.com/office/drawing/2010/main" mc:Ignorable="a14">
+              <mc:Choice Requires="a14">
+                <a14:m>
+                  <m:oMath xmlns:m="http://schemas.openxmlformats.org/officeDocument/2006/math">
+                    <m:r>
+                      <m:rPr>
+                        <m:sz m:val="38"/>
+                      </m:rPr>
+                      <m:t>P{min{</m:t>
+                    </m:r>
+                    <m:sSub>
+                      <m:e>
+                        <m:r>
+                          <m:rPr>
+                            <m:sz m:val="38"/>
+                          </m:rPr>
+                          <m:t>X</m:t>
+                        </m:r>
+                      </m:e>
+                      <m:sub>
+                        <m:r>
+                          <m:rPr>
+                            <m:sz m:val="38"/>
+                          </m:rPr>
+                          <m:t>1</m:t>
+                        </m:r>
+                      </m:sub>
+                    </m:sSub>
+                    <m:r>
+                      <m:rPr>
+                        <m:sz m:val="38"/>
+                      </m:rPr>
+                      <m:t>,…,</m:t>
+                    </m:r>
+                    <m:sSub>
+                      <m:e>
+                        <m:r>
+                          <m:rPr>
+                            <m:sz m:val="38"/>
+                          </m:rPr>
+                          <m:t>X</m:t>
+                        </m:r>
+                      </m:e>
+                      <m:sub>
+                        <m:r>
+                          <m:rPr>
+                            <m:sz m:val="38"/>
+                          </m:rPr>
+                          <m:t>n</m:t>
+                        </m:r>
+                      </m:sub>
+                    </m:sSub>
+                    <m:r>
+                      <m:rPr>
+                        <m:sz m:val="38"/>
+                      </m:rPr>
+                      <m:t>}&gt;x}=P{</m:t>
+                    </m:r>
+                    <m:sSub>
+                      <m:e>
+                        <m:r>
+                          <m:rPr>
+                            <m:sz m:val="38"/>
+                          </m:rPr>
+                          <m:t>X</m:t>
+                        </m:r>
+                      </m:e>
+                      <m:sub>
+                        <m:r>
+                          <m:rPr>
+                            <m:sz m:val="38"/>
+                          </m:rPr>
+                          <m:t>1</m:t>
+                        </m:r>
+                      </m:sub>
+                    </m:sSub>
+                    <m:r>
+                      <m:rPr>
+                        <m:sz m:val="38"/>
+                      </m:rPr>
+                      <m:t>&gt;x,</m:t>
+                    </m:r>
+                    <m:sSub>
+                      <m:e>
+                        <m:r>
+                          <m:rPr>
+                            <m:sz m:val="38"/>
+                          </m:rPr>
+                          <m:t>X</m:t>
+                        </m:r>
+                      </m:e>
+                      <m:sub>
+                        <m:r>
+                          <m:rPr>
+                            <m:sz m:val="38"/>
+                          </m:rPr>
+                          <m:t>2</m:t>
+                        </m:r>
+                      </m:sub>
+                    </m:sSub>
+                    <m:r>
+                      <m:rPr>
+                        <m:sz m:val="38"/>
+                      </m:rPr>
+                      <m:t>&gt;x,…,</m:t>
+                    </m:r>
+                    <m:sSub>
+                      <m:e>
+                        <m:r>
+                          <m:rPr>
+                            <m:sz m:val="38"/>
+                          </m:rPr>
+                          <m:t>X</m:t>
+                        </m:r>
+                      </m:e>
+                      <m:sub>
+                        <m:r>
+                          <m:rPr>
+                            <m:sz m:val="38"/>
+                          </m:rPr>
+                          <m:t>n</m:t>
+                        </m:r>
+                      </m:sub>
+                    </m:sSub>
+                    <m:r>
+                      <m:rPr>
+                        <m:sz m:val="38"/>
+                      </m:rPr>
+                      <m:t>&gt;x}=</m:t>
+                    </m:r>
+                    <m:sSup>
+                      <m:e>
+                        <m:d>
+                          <m:dPr>
+                            <m:sepChr m:val=""/>
+                          </m:dPr>
+                          <m:e>
+                            <m:f>
+                              <m:fPr>
+                                <m:type m:val="bar"/>
+                              </m:fPr>
+                              <m:num>
+                                <m:r>
+                                  <m:rPr>
+                                    <m:sz m:val="38"/>
+                                  </m:rPr>
+                                  <m:t>1−x</m:t>
+                                </m:r>
+                              </m:num>
+                              <m:den>
+                                <m:r>
+                                  <m:rPr>
+                                    <m:sz m:val="38"/>
+                                  </m:rPr>
+                                  <m:t>2</m:t>
+                                </m:r>
+                              </m:den>
+                            </m:f>
+                          </m:e>
+                        </m:d>
+                      </m:e>
+                      <m:sup>
+                        <m:r>
+                          <m:rPr>
+                            <m:sz m:val="38"/>
+                          </m:rPr>
+                          <m:t>n</m:t>
+                        </m:r>
+                      </m:sup>
+                    </m:sSup>
+                  </m:oMath>
+                </a14:m>
+              </mc:Choice>
+              <mc:Fallback>
+                <a:r>
+                  <a:t>P{min{X1,…,Xn}&gt;x}=P{X1&gt;x,X2&gt;x,…,Xn&gt;x}=(1−x2)n</a:t>
+                </a:r>
+              </mc:Fallback>
+            </mc:AlternateContent>
           </a:p>
           <a:p>
             <a:pPr>
@@ -4709,8 +7702,155 @@
                 </a:solidFill>
                 <a:latin typeface="Microsoft YaHei"/>
               </a:rPr>
-              <a:t>▶ 因此密度函数为 −∂/∂x ((1 − x)/2)ⁿ = n/2 · ((1 − x)/2)ⁿ⁻¹。</a:t>
-            </a:r>
+              <a:t>▶ 因此密度函数为 </a:t>
+            </a:r>
+            <mc:AlternateContent xmlns:mc="http://schemas.openxmlformats.org/markup-compatibility/2006" xmlns:a14="http://schemas.microsoft.com/office/drawing/2010/main" mc:Ignorable="a14">
+              <mc:Choice Requires="a14">
+                <a14:m>
+                  <m:oMath xmlns:m="http://schemas.openxmlformats.org/officeDocument/2006/math">
+                    <m:r>
+                      <m:rPr>
+                        <m:sz m:val="38"/>
+                      </m:rPr>
+                      <m:t>−</m:t>
+                    </m:r>
+                    <m:f>
+                      <m:fPr>
+                        <m:type m:val="bar"/>
+                      </m:fPr>
+                      <m:num>
+                        <m:r>
+                          <m:rPr>
+                            <m:sz m:val="38"/>
+                          </m:rPr>
+                          <m:t>∂</m:t>
+                        </m:r>
+                      </m:num>
+                      <m:den>
+                        <m:r>
+                          <m:rPr>
+                            <m:sz m:val="38"/>
+                          </m:rPr>
+                          <m:t>∂x</m:t>
+                        </m:r>
+                      </m:den>
+                    </m:f>
+                    <m:sSup>
+                      <m:e>
+                        <m:d>
+                          <m:dPr>
+                            <m:sepChr m:val=""/>
+                          </m:dPr>
+                          <m:e>
+                            <m:f>
+                              <m:fPr>
+                                <m:type m:val="bar"/>
+                              </m:fPr>
+                              <m:num>
+                                <m:r>
+                                  <m:rPr>
+                                    <m:sz m:val="38"/>
+                                  </m:rPr>
+                                  <m:t>1−x</m:t>
+                                </m:r>
+                              </m:num>
+                              <m:den>
+                                <m:r>
+                                  <m:rPr>
+                                    <m:sz m:val="38"/>
+                                  </m:rPr>
+                                  <m:t>2</m:t>
+                                </m:r>
+                              </m:den>
+                            </m:f>
+                          </m:e>
+                        </m:d>
+                      </m:e>
+                      <m:sup>
+                        <m:r>
+                          <m:rPr>
+                            <m:sz m:val="38"/>
+                          </m:rPr>
+                          <m:t>n</m:t>
+                        </m:r>
+                      </m:sup>
+                    </m:sSup>
+                    <m:r>
+                      <m:rPr>
+                        <m:sz m:val="38"/>
+                      </m:rPr>
+                      <m:t>=</m:t>
+                    </m:r>
+                    <m:f>
+                      <m:fPr>
+                        <m:type m:val="bar"/>
+                      </m:fPr>
+                      <m:num>
+                        <m:r>
+                          <m:rPr>
+                            <m:sz m:val="38"/>
+                          </m:rPr>
+                          <m:t>n</m:t>
+                        </m:r>
+                      </m:num>
+                      <m:den>
+                        <m:r>
+                          <m:rPr>
+                            <m:sz m:val="38"/>
+                          </m:rPr>
+                          <m:t>2</m:t>
+                        </m:r>
+                      </m:den>
+                    </m:f>
+                    <m:sSup>
+                      <m:e>
+                        <m:d>
+                          <m:dPr>
+                            <m:sepChr m:val=""/>
+                          </m:dPr>
+                          <m:e>
+                            <m:f>
+                              <m:fPr>
+                                <m:type m:val="bar"/>
+                              </m:fPr>
+                              <m:num>
+                                <m:r>
+                                  <m:rPr>
+                                    <m:sz m:val="38"/>
+                                  </m:rPr>
+                                  <m:t>1−x</m:t>
+                                </m:r>
+                              </m:num>
+                              <m:den>
+                                <m:r>
+                                  <m:rPr>
+                                    <m:sz m:val="38"/>
+                                  </m:rPr>
+                                  <m:t>2</m:t>
+                                </m:r>
+                              </m:den>
+                            </m:f>
+                          </m:e>
+                        </m:d>
+                      </m:e>
+                      <m:sup>
+                        <m:r>
+                          <m:rPr>
+                            <m:sz m:val="38"/>
+                          </m:rPr>
+                          <m:t>n−1</m:t>
+                        </m:r>
+                      </m:sup>
+                    </m:sSup>
+                  </m:oMath>
+                </a14:m>
+              </mc:Choice>
+              <mc:Fallback>
+                <a:r>
+                  <a:t>−∂∂x(1−x2)n=n2(1−x2)n−1</a:t>
+                </a:r>
+              </mc:Fallback>
+            </mc:AlternateContent>
           </a:p>
         </p:txBody>
       </p:sp>
@@ -4808,8 +7948,8 @@
         </p:nvSpPr>
         <p:spPr>
           <a:xfrm>
-            <a:off x="502920" y="1005840"/>
-            <a:ext cx="11155680" cy="4846320"/>
+            <a:off x="502920" y="1051560"/>
+            <a:ext cx="11155680" cy="4937760"/>
           </a:xfrm>
           <a:prstGeom prst="rect">
             <a:avLst/>
@@ -4834,7 +7974,149 @@
                 </a:solidFill>
                 <a:latin typeface="Microsoft YaHei"/>
               </a:rPr>
-              <a:t>▶ 设 Xᵢ 为随机变量 X 的独立副本，M_X(t) 为 X 的矩生成函数。</a:t>
+              <a:t>▶ 设 </a:t>
+            </a:r>
+            <mc:AlternateContent xmlns:mc="http://schemas.openxmlformats.org/markup-compatibility/2006" xmlns:a14="http://schemas.microsoft.com/office/drawing/2010/main" mc:Ignorable="a14">
+              <mc:Choice Requires="a14">
+                <a14:m>
+                  <m:oMath xmlns:m="http://schemas.openxmlformats.org/officeDocument/2006/math">
+                    <m:sSub>
+                      <m:e>
+                        <m:r>
+                          <m:rPr>
+                            <m:sz m:val="38"/>
+                          </m:rPr>
+                          <m:t>X</m:t>
+                        </m:r>
+                      </m:e>
+                      <m:sub>
+                        <m:r>
+                          <m:rPr>
+                            <m:sz m:val="38"/>
+                          </m:rPr>
+                          <m:t>i</m:t>
+                        </m:r>
+                      </m:sub>
+                    </m:sSub>
+                  </m:oMath>
+                </a14:m>
+              </mc:Choice>
+              <mc:Fallback>
+                <a:r>
+                  <a:t>Xi</a:t>
+                </a:r>
+              </mc:Fallback>
+            </mc:AlternateContent>
+            <a:r>
+              <a:rPr sz="1900">
+                <a:solidFill>
+                  <a:srgbClr val="202020"/>
+                </a:solidFill>
+                <a:latin typeface="Microsoft YaHei"/>
+              </a:rPr>
+              <a:t> 为随机变量 </a:t>
+            </a:r>
+            <mc:AlternateContent xmlns:mc="http://schemas.openxmlformats.org/markup-compatibility/2006" xmlns:a14="http://schemas.microsoft.com/office/drawing/2010/main" mc:Ignorable="a14">
+              <mc:Choice Requires="a14">
+                <a14:m>
+                  <m:oMath xmlns:m="http://schemas.openxmlformats.org/officeDocument/2006/math">
+                    <m:r>
+                      <m:rPr>
+                        <m:sz m:val="38"/>
+                      </m:rPr>
+                      <m:t>X</m:t>
+                    </m:r>
+                  </m:oMath>
+                </a14:m>
+              </mc:Choice>
+              <mc:Fallback>
+                <a:r>
+                  <a:t>X</a:t>
+                </a:r>
+              </mc:Fallback>
+            </mc:AlternateContent>
+            <a:r>
+              <a:rPr sz="1900">
+                <a:solidFill>
+                  <a:srgbClr val="202020"/>
+                </a:solidFill>
+                <a:latin typeface="Microsoft YaHei"/>
+              </a:rPr>
+              <a:t> 的独立副本，</a:t>
+            </a:r>
+            <mc:AlternateContent xmlns:mc="http://schemas.openxmlformats.org/markup-compatibility/2006" xmlns:a14="http://schemas.microsoft.com/office/drawing/2010/main" mc:Ignorable="a14">
+              <mc:Choice Requires="a14">
+                <a14:m>
+                  <m:oMath xmlns:m="http://schemas.openxmlformats.org/officeDocument/2006/math">
+                    <m:sSub>
+                      <m:e>
+                        <m:r>
+                          <m:rPr>
+                            <m:sz m:val="38"/>
+                          </m:rPr>
+                          <m:t>M</m:t>
+                        </m:r>
+                      </m:e>
+                      <m:sub>
+                        <m:r>
+                          <m:rPr>
+                            <m:sz m:val="38"/>
+                          </m:rPr>
+                          <m:t>X</m:t>
+                        </m:r>
+                      </m:sub>
+                    </m:sSub>
+                    <m:r>
+                      <m:rPr>
+                        <m:sz m:val="38"/>
+                      </m:rPr>
+                      <m:t>(t)</m:t>
+                    </m:r>
+                  </m:oMath>
+                </a14:m>
+              </mc:Choice>
+              <mc:Fallback>
+                <a:r>
+                  <a:t>MX(t)</a:t>
+                </a:r>
+              </mc:Fallback>
+            </mc:AlternateContent>
+            <a:r>
+              <a:rPr sz="1900">
+                <a:solidFill>
+                  <a:srgbClr val="202020"/>
+                </a:solidFill>
+                <a:latin typeface="Microsoft YaHei"/>
+              </a:rPr>
+              <a:t> 为 </a:t>
+            </a:r>
+            <mc:AlternateContent xmlns:mc="http://schemas.openxmlformats.org/markup-compatibility/2006" xmlns:a14="http://schemas.microsoft.com/office/drawing/2010/main" mc:Ignorable="a14">
+              <mc:Choice Requires="a14">
+                <a14:m>
+                  <m:oMath xmlns:m="http://schemas.openxmlformats.org/officeDocument/2006/math">
+                    <m:r>
+                      <m:rPr>
+                        <m:sz m:val="38"/>
+                      </m:rPr>
+                      <m:t>X</m:t>
+                    </m:r>
+                  </m:oMath>
+                </a14:m>
+              </mc:Choice>
+              <mc:Fallback>
+                <a:r>
+                  <a:t>X</a:t>
+                </a:r>
+              </mc:Fallback>
+            </mc:AlternateContent>
+            <a:r>
+              <a:rPr sz="1900">
+                <a:solidFill>
+                  <a:srgbClr val="202020"/>
+                </a:solidFill>
+                <a:latin typeface="Microsoft YaHei"/>
+              </a:rPr>
+              <a:t> 的矩生成函数。</a:t>
             </a:r>
           </a:p>
           <a:p>
@@ -4850,7 +8132,160 @@
                 </a:solidFill>
                 <a:latin typeface="Microsoft YaHei"/>
               </a:rPr>
-              <a:t>▶ 用 M_X(t) 与 n 表示平均值 Σᵢ₌₁ⁿ Xᵢ / n 的矩生成函数。</a:t>
+              <a:t>▶ 用 </a:t>
+            </a:r>
+            <mc:AlternateContent xmlns:mc="http://schemas.openxmlformats.org/markup-compatibility/2006" xmlns:a14="http://schemas.microsoft.com/office/drawing/2010/main" mc:Ignorable="a14">
+              <mc:Choice Requires="a14">
+                <a14:m>
+                  <m:oMath xmlns:m="http://schemas.openxmlformats.org/officeDocument/2006/math">
+                    <m:sSub>
+                      <m:e>
+                        <m:r>
+                          <m:rPr>
+                            <m:sz m:val="38"/>
+                          </m:rPr>
+                          <m:t>M</m:t>
+                        </m:r>
+                      </m:e>
+                      <m:sub>
+                        <m:r>
+                          <m:rPr>
+                            <m:sz m:val="38"/>
+                          </m:rPr>
+                          <m:t>X</m:t>
+                        </m:r>
+                      </m:sub>
+                    </m:sSub>
+                    <m:r>
+                      <m:rPr>
+                        <m:sz m:val="38"/>
+                      </m:rPr>
+                      <m:t>(t)</m:t>
+                    </m:r>
+                  </m:oMath>
+                </a14:m>
+              </mc:Choice>
+              <mc:Fallback>
+                <a:r>
+                  <a:t>MX(t)</a:t>
+                </a:r>
+              </mc:Fallback>
+            </mc:AlternateContent>
+            <a:r>
+              <a:rPr sz="1900">
+                <a:solidFill>
+                  <a:srgbClr val="202020"/>
+                </a:solidFill>
+                <a:latin typeface="Microsoft YaHei"/>
+              </a:rPr>
+              <a:t> 与 </a:t>
+            </a:r>
+            <mc:AlternateContent xmlns:mc="http://schemas.openxmlformats.org/markup-compatibility/2006" xmlns:a14="http://schemas.microsoft.com/office/drawing/2010/main" mc:Ignorable="a14">
+              <mc:Choice Requires="a14">
+                <a14:m>
+                  <m:oMath xmlns:m="http://schemas.openxmlformats.org/officeDocument/2006/math">
+                    <m:r>
+                      <m:rPr>
+                        <m:sz m:val="38"/>
+                      </m:rPr>
+                      <m:t>n</m:t>
+                    </m:r>
+                  </m:oMath>
+                </a14:m>
+              </mc:Choice>
+              <mc:Fallback>
+                <a:r>
+                  <a:t>n</a:t>
+                </a:r>
+              </mc:Fallback>
+            </mc:AlternateContent>
+            <a:r>
+              <a:rPr sz="1900">
+                <a:solidFill>
+                  <a:srgbClr val="202020"/>
+                </a:solidFill>
+                <a:latin typeface="Microsoft YaHei"/>
+              </a:rPr>
+              <a:t> 表示平均值 </a:t>
+            </a:r>
+            <mc:AlternateContent xmlns:mc="http://schemas.openxmlformats.org/markup-compatibility/2006" xmlns:a14="http://schemas.microsoft.com/office/drawing/2010/main" mc:Ignorable="a14">
+              <mc:Choice Requires="a14">
+                <a14:m>
+                  <m:oMath xmlns:m="http://schemas.openxmlformats.org/officeDocument/2006/math">
+                    <m:nary>
+                      <m:naryPr>
+                        <m:chr m:val="∑"/>
+                        <m:limLoc m:val="subSup"/>
+                        <m:grow m:val="1"/>
+                        <m:subHide m:val="off"/>
+                        <m:supHide m:val="off"/>
+                      </m:naryPr>
+                      <m:sub>
+                        <m:r>
+                          <m:rPr>
+                            <m:sz m:val="38"/>
+                          </m:rPr>
+                          <m:t>i=1</m:t>
+                        </m:r>
+                      </m:sub>
+                      <m:sup>
+                        <m:r>
+                          <m:rPr>
+                            <m:sz m:val="38"/>
+                          </m:rPr>
+                          <m:t>n</m:t>
+                        </m:r>
+                      </m:sup>
+                      <m:e>
+                        <m:sSub>
+                          <m:e>
+                            <m:r>
+                              <m:rPr>
+                                <m:sz m:val="38"/>
+                              </m:rPr>
+                              <m:t>X</m:t>
+                            </m:r>
+                          </m:e>
+                          <m:sub>
+                            <m:r>
+                              <m:rPr>
+                                <m:sz m:val="38"/>
+                              </m:rPr>
+                              <m:t>i</m:t>
+                            </m:r>
+                          </m:sub>
+                        </m:sSub>
+                      </m:e>
+                    </m:nary>
+                    <m:r>
+                      <m:rPr>
+                        <m:sz m:val="38"/>
+                      </m:rPr>
+                      <m:t>/</m:t>
+                    </m:r>
+                    <m:r>
+                      <m:rPr>
+                        <m:sz m:val="38"/>
+                      </m:rPr>
+                      <m:t>n</m:t>
+                    </m:r>
+                  </m:oMath>
+                </a14:m>
+              </mc:Choice>
+              <mc:Fallback>
+                <a:r>
+                  <a:t>∑i=1nXi/n</a:t>
+                </a:r>
+              </mc:Fallback>
+            </mc:AlternateContent>
+            <a:r>
+              <a:rPr sz="1900">
+                <a:solidFill>
+                  <a:srgbClr val="202020"/>
+                </a:solidFill>
+                <a:latin typeface="Microsoft YaHei"/>
+              </a:rPr>
+              <a:t> 的矩生成函数。</a:t>
             </a:r>
           </a:p>
         </p:txBody>
@@ -4949,8 +8384,8 @@
         </p:nvSpPr>
         <p:spPr>
           <a:xfrm>
-            <a:off x="502920" y="1005840"/>
-            <a:ext cx="11155680" cy="4846320"/>
+            <a:off x="502920" y="1051560"/>
+            <a:ext cx="11155680" cy="4937760"/>
           </a:xfrm>
           <a:prstGeom prst="rect">
             <a:avLst/>
@@ -4975,24 +8410,296 @@
                 </a:solidFill>
                 <a:latin typeface="Microsoft YaHei"/>
               </a:rPr>
-              <a:t>▶ 记 Y = Σᵢ₌₁ⁿ Xᵢ / n，则</a:t>
-            </a:r>
-          </a:p>
-          <a:p>
-            <a:pPr lvl="1">
+              <a:t>▶ 记 </a:t>
+            </a:r>
+            <mc:AlternateContent xmlns:mc="http://schemas.openxmlformats.org/markup-compatibility/2006" xmlns:a14="http://schemas.microsoft.com/office/drawing/2010/main" mc:Ignorable="a14">
+              <mc:Choice Requires="a14">
+                <a14:m>
+                  <m:oMath xmlns:m="http://schemas.openxmlformats.org/officeDocument/2006/math">
+                    <m:r>
+                      <m:rPr>
+                        <m:sz m:val="38"/>
+                      </m:rPr>
+                      <m:t>Y=</m:t>
+                    </m:r>
+                    <m:nary>
+                      <m:naryPr>
+                        <m:chr m:val="∑"/>
+                        <m:limLoc m:val="subSup"/>
+                        <m:grow m:val="1"/>
+                        <m:subHide m:val="off"/>
+                        <m:supHide m:val="off"/>
+                      </m:naryPr>
+                      <m:sub>
+                        <m:r>
+                          <m:rPr>
+                            <m:sz m:val="38"/>
+                          </m:rPr>
+                          <m:t>i=1</m:t>
+                        </m:r>
+                      </m:sub>
+                      <m:sup>
+                        <m:r>
+                          <m:rPr>
+                            <m:sz m:val="38"/>
+                          </m:rPr>
+                          <m:t>n</m:t>
+                        </m:r>
+                      </m:sup>
+                      <m:e>
+                        <m:sSub>
+                          <m:e>
+                            <m:r>
+                              <m:rPr>
+                                <m:sz m:val="38"/>
+                              </m:rPr>
+                              <m:t>X</m:t>
+                            </m:r>
+                          </m:e>
+                          <m:sub>
+                            <m:r>
+                              <m:rPr>
+                                <m:sz m:val="38"/>
+                              </m:rPr>
+                              <m:t>i</m:t>
+                            </m:r>
+                          </m:sub>
+                        </m:sSub>
+                      </m:e>
+                    </m:nary>
+                    <m:r>
+                      <m:rPr>
+                        <m:sz m:val="38"/>
+                      </m:rPr>
+                      <m:t>/</m:t>
+                    </m:r>
+                    <m:r>
+                      <m:rPr>
+                        <m:sz m:val="38"/>
+                      </m:rPr>
+                      <m:t>n</m:t>
+                    </m:r>
+                  </m:oMath>
+                </a14:m>
+              </mc:Choice>
+              <mc:Fallback>
+                <a:r>
+                  <a:t>Y=∑i=1nXi/n</a:t>
+                </a:r>
+              </mc:Fallback>
+            </mc:AlternateContent>
+            <a:r>
+              <a:rPr sz="1900">
+                <a:solidFill>
+                  <a:srgbClr val="202020"/>
+                </a:solidFill>
+                <a:latin typeface="Microsoft YaHei"/>
+              </a:rPr>
+              <a:t>，则</a:t>
+            </a:r>
+          </a:p>
+          <a:p>
+            <a:pPr>
               <a:spcAft>
                 <a:spcPts val="1000"/>
               </a:spcAft>
             </a:pPr>
-            <a:r>
-              <a:rPr sz="1700">
-                <a:solidFill>
-                  <a:srgbClr val="404040"/>
-                </a:solidFill>
-                <a:latin typeface="Microsoft YaHei"/>
-              </a:rPr>
-              <a:t>M_Y(t) = E[e^{tY}] = E[e^{t·Σᵢ₌₁ⁿ Xᵢ/n}] = (M_X(t/n))ⁿ</a:t>
-            </a:r>
+            <mc:AlternateContent xmlns:mc="http://schemas.openxmlformats.org/markup-compatibility/2006" xmlns:a14="http://schemas.microsoft.com/office/drawing/2010/main" mc:Ignorable="a14">
+              <mc:Choice Requires="a14">
+                <a14:m>
+                  <m:oMath xmlns:m="http://schemas.openxmlformats.org/officeDocument/2006/math">
+                    <m:sSub>
+                      <m:e>
+                        <m:r>
+                          <m:rPr>
+                            <m:sz m:val="38"/>
+                          </m:rPr>
+                          <m:t>M</m:t>
+                        </m:r>
+                      </m:e>
+                      <m:sub>
+                        <m:r>
+                          <m:rPr>
+                            <m:sz m:val="38"/>
+                          </m:rPr>
+                          <m:t>Y</m:t>
+                        </m:r>
+                      </m:sub>
+                    </m:sSub>
+                    <m:r>
+                      <m:rPr>
+                        <m:sz m:val="38"/>
+                      </m:rPr>
+                      <m:t>(t)=E</m:t>
+                    </m:r>
+                    <m:d>
+                      <m:dPr>
+                        <m:begChr m:val="["/>
+                        <m:sepChr m:val=""/>
+                        <m:endChr m:val="]"/>
+                      </m:dPr>
+                      <m:e>
+                        <m:sSup>
+                          <m:e>
+                            <m:r>
+                              <m:rPr>
+                                <m:sz m:val="38"/>
+                              </m:rPr>
+                              <m:t>e</m:t>
+                            </m:r>
+                          </m:e>
+                          <m:sup>
+                            <m:r>
+                              <m:rPr>
+                                <m:sz m:val="38"/>
+                              </m:rPr>
+                              <m:t>tY</m:t>
+                            </m:r>
+                          </m:sup>
+                        </m:sSup>
+                      </m:e>
+                    </m:d>
+                    <m:r>
+                      <m:rPr>
+                        <m:sz m:val="38"/>
+                      </m:rPr>
+                      <m:t>=E</m:t>
+                    </m:r>
+                    <m:d>
+                      <m:dPr>
+                        <m:begChr m:val="["/>
+                        <m:sepChr m:val=""/>
+                        <m:endChr m:val="]"/>
+                      </m:dPr>
+                      <m:e>
+                        <m:sSup>
+                          <m:e>
+                            <m:r>
+                              <m:rPr>
+                                <m:sz m:val="38"/>
+                              </m:rPr>
+                              <m:t>e</m:t>
+                            </m:r>
+                          </m:e>
+                          <m:sup>
+                            <m:r>
+                              <m:rPr>
+                                <m:sz m:val="38"/>
+                              </m:rPr>
+                              <m:t>t</m:t>
+                            </m:r>
+                            <m:nary>
+                              <m:naryPr>
+                                <m:chr m:val="∑"/>
+                                <m:limLoc m:val="subSup"/>
+                                <m:grow m:val="1"/>
+                                <m:subHide m:val="off"/>
+                                <m:supHide m:val="off"/>
+                              </m:naryPr>
+                              <m:sub>
+                                <m:r>
+                                  <m:rPr>
+                                    <m:sz m:val="38"/>
+                                  </m:rPr>
+                                  <m:t>i=1</m:t>
+                                </m:r>
+                              </m:sub>
+                              <m:sup>
+                                <m:r>
+                                  <m:rPr>
+                                    <m:sz m:val="38"/>
+                                  </m:rPr>
+                                  <m:t>n</m:t>
+                                </m:r>
+                              </m:sup>
+                              <m:e>
+                                <m:sSub>
+                                  <m:e>
+                                    <m:r>
+                                      <m:rPr>
+                                        <m:sz m:val="38"/>
+                                      </m:rPr>
+                                      <m:t>X</m:t>
+                                    </m:r>
+                                  </m:e>
+                                  <m:sub>
+                                    <m:r>
+                                      <m:rPr>
+                                        <m:sz m:val="38"/>
+                                      </m:rPr>
+                                      <m:t>i</m:t>
+                                    </m:r>
+                                  </m:sub>
+                                </m:sSub>
+                              </m:e>
+                            </m:nary>
+                            <m:r>
+                              <m:rPr>
+                                <m:sz m:val="38"/>
+                              </m:rPr>
+                              <m:t>/n</m:t>
+                            </m:r>
+                          </m:sup>
+                        </m:sSup>
+                      </m:e>
+                    </m:d>
+                    <m:r>
+                      <m:rPr>
+                        <m:sz m:val="38"/>
+                      </m:rPr>
+                      <m:t>=(</m:t>
+                    </m:r>
+                    <m:sSub>
+                      <m:e>
+                        <m:r>
+                          <m:rPr>
+                            <m:sz m:val="38"/>
+                          </m:rPr>
+                          <m:t>M</m:t>
+                        </m:r>
+                      </m:e>
+                      <m:sub>
+                        <m:r>
+                          <m:rPr>
+                            <m:sz m:val="38"/>
+                          </m:rPr>
+                          <m:t>X</m:t>
+                        </m:r>
+                      </m:sub>
+                    </m:sSub>
+                    <m:r>
+                      <m:rPr>
+                        <m:sz m:val="38"/>
+                      </m:rPr>
+                      <m:t>(t/n)</m:t>
+                    </m:r>
+                    <m:sSup>
+                      <m:e>
+                        <m:r>
+                          <m:rPr>
+                            <m:sz m:val="38"/>
+                          </m:rPr>
+                          <m:t>)</m:t>
+                        </m:r>
+                      </m:e>
+                      <m:sup>
+                        <m:r>
+                          <m:rPr>
+                            <m:sz m:val="38"/>
+                          </m:rPr>
+                          <m:t>n</m:t>
+                        </m:r>
+                      </m:sup>
+                    </m:sSup>
+                  </m:oMath>
+                </a14:m>
+              </mc:Choice>
+              <mc:Fallback>
+                <a:r>
+                  <a:t>MY(t)=E[etY]=E[et∑i=1nXi/n]=(MX(t/n))n</a:t>
+                </a:r>
+              </mc:Fallback>
+            </mc:AlternateContent>
           </a:p>
         </p:txBody>
       </p:sp>
@@ -5090,8 +8797,8 @@
         </p:nvSpPr>
         <p:spPr>
           <a:xfrm>
-            <a:off x="502920" y="1005840"/>
-            <a:ext cx="11155680" cy="4846320"/>
+            <a:off x="502920" y="1051560"/>
+            <a:ext cx="11155680" cy="4937760"/>
           </a:xfrm>
           <a:prstGeom prst="rect">
             <a:avLst/>
@@ -5116,7 +8823,149 @@
                 </a:solidFill>
                 <a:latin typeface="Microsoft YaHei"/>
               </a:rPr>
-              <a:t>▶ 设 X、Y 为独立随机变量，各以概率 1/3 取值 1，以概率 2/3 取值 2。</a:t>
+              <a:t>▶ 设 </a:t>
+            </a:r>
+            <mc:AlternateContent xmlns:mc="http://schemas.openxmlformats.org/markup-compatibility/2006" xmlns:a14="http://schemas.microsoft.com/office/drawing/2010/main" mc:Ignorable="a14">
+              <mc:Choice Requires="a14">
+                <a14:m>
+                  <m:oMath xmlns:m="http://schemas.openxmlformats.org/officeDocument/2006/math">
+                    <m:r>
+                      <m:rPr>
+                        <m:sz m:val="38"/>
+                      </m:rPr>
+                      <m:t>X</m:t>
+                    </m:r>
+                  </m:oMath>
+                </a14:m>
+              </mc:Choice>
+              <mc:Fallback>
+                <a:r>
+                  <a:t>X</a:t>
+                </a:r>
+              </mc:Fallback>
+            </mc:AlternateContent>
+            <a:r>
+              <a:rPr sz="1900">
+                <a:solidFill>
+                  <a:srgbClr val="202020"/>
+                </a:solidFill>
+                <a:latin typeface="Microsoft YaHei"/>
+              </a:rPr>
+              <a:t>、</a:t>
+            </a:r>
+            <mc:AlternateContent xmlns:mc="http://schemas.openxmlformats.org/markup-compatibility/2006" xmlns:a14="http://schemas.microsoft.com/office/drawing/2010/main" mc:Ignorable="a14">
+              <mc:Choice Requires="a14">
+                <a14:m>
+                  <m:oMath xmlns:m="http://schemas.openxmlformats.org/officeDocument/2006/math">
+                    <m:r>
+                      <m:rPr>
+                        <m:sz m:val="38"/>
+                      </m:rPr>
+                      <m:t>Y</m:t>
+                    </m:r>
+                  </m:oMath>
+                </a14:m>
+              </mc:Choice>
+              <mc:Fallback>
+                <a:r>
+                  <a:t>Y</a:t>
+                </a:r>
+              </mc:Fallback>
+            </mc:AlternateContent>
+            <a:r>
+              <a:rPr sz="1900">
+                <a:solidFill>
+                  <a:srgbClr val="202020"/>
+                </a:solidFill>
+                <a:latin typeface="Microsoft YaHei"/>
+              </a:rPr>
+              <a:t> 为独立随机变量，各以概率 </a:t>
+            </a:r>
+            <mc:AlternateContent xmlns:mc="http://schemas.openxmlformats.org/markup-compatibility/2006" xmlns:a14="http://schemas.microsoft.com/office/drawing/2010/main" mc:Ignorable="a14">
+              <mc:Choice Requires="a14">
+                <a14:m>
+                  <m:oMath xmlns:m="http://schemas.openxmlformats.org/officeDocument/2006/math">
+                    <m:f>
+                      <m:fPr>
+                        <m:type m:val="lin"/>
+                      </m:fPr>
+                      <m:num>
+                        <m:r>
+                          <m:rPr>
+                            <m:sz m:val="38"/>
+                          </m:rPr>
+                          <m:t>1</m:t>
+                        </m:r>
+                      </m:num>
+                      <m:den>
+                        <m:r>
+                          <m:rPr>
+                            <m:sz m:val="38"/>
+                          </m:rPr>
+                          <m:t>3</m:t>
+                        </m:r>
+                      </m:den>
+                    </m:f>
+                  </m:oMath>
+                </a14:m>
+              </mc:Choice>
+              <mc:Fallback>
+                <a:r>
+                  <a:t>1/3</a:t>
+                </a:r>
+              </mc:Fallback>
+            </mc:AlternateContent>
+            <a:r>
+              <a:rPr sz="1900">
+                <a:solidFill>
+                  <a:srgbClr val="202020"/>
+                </a:solidFill>
+                <a:latin typeface="Microsoft YaHei"/>
+              </a:rPr>
+              <a:t> 取值 1，以概率 </a:t>
+            </a:r>
+            <mc:AlternateContent xmlns:mc="http://schemas.openxmlformats.org/markup-compatibility/2006" xmlns:a14="http://schemas.microsoft.com/office/drawing/2010/main" mc:Ignorable="a14">
+              <mc:Choice Requires="a14">
+                <a14:m>
+                  <m:oMath xmlns:m="http://schemas.openxmlformats.org/officeDocument/2006/math">
+                    <m:f>
+                      <m:fPr>
+                        <m:type m:val="lin"/>
+                      </m:fPr>
+                      <m:num>
+                        <m:r>
+                          <m:rPr>
+                            <m:sz m:val="38"/>
+                          </m:rPr>
+                          <m:t>2</m:t>
+                        </m:r>
+                      </m:num>
+                      <m:den>
+                        <m:r>
+                          <m:rPr>
+                            <m:sz m:val="38"/>
+                          </m:rPr>
+                          <m:t>3</m:t>
+                        </m:r>
+                      </m:den>
+                    </m:f>
+                  </m:oMath>
+                </a14:m>
+              </mc:Choice>
+              <mc:Fallback>
+                <a:r>
+                  <a:t>2/3</a:t>
+                </a:r>
+              </mc:Fallback>
+            </mc:AlternateContent>
+            <a:r>
+              <a:rPr sz="1900">
+                <a:solidFill>
+                  <a:srgbClr val="202020"/>
+                </a:solidFill>
+                <a:latin typeface="Microsoft YaHei"/>
+              </a:rPr>
+              <a:t> 取值 2。</a:t>
             </a:r>
           </a:p>
           <a:p>
@@ -5132,8 +8981,27 @@
                 </a:solidFill>
                 <a:latin typeface="Microsoft YaHei"/>
               </a:rPr>
-              <a:t>▶ 计算熵 H(X)。</a:t>
-            </a:r>
+              <a:t>▶ 计算熵 </a:t>
+            </a:r>
+            <mc:AlternateContent xmlns:mc="http://schemas.openxmlformats.org/markup-compatibility/2006" xmlns:a14="http://schemas.microsoft.com/office/drawing/2010/main" mc:Ignorable="a14">
+              <mc:Choice Requires="a14">
+                <a14:m>
+                  <m:oMath xmlns:m="http://schemas.openxmlformats.org/officeDocument/2006/math">
+                    <m:r>
+                      <m:rPr>
+                        <m:sz m:val="38"/>
+                      </m:rPr>
+                      <m:t>H(X)</m:t>
+                    </m:r>
+                  </m:oMath>
+                </a14:m>
+              </mc:Choice>
+              <mc:Fallback>
+                <a:r>
+                  <a:t>H(X)</a:t>
+                </a:r>
+              </mc:Fallback>
+            </mc:AlternateContent>
           </a:p>
         </p:txBody>
       </p:sp>

</xml_diff>